<commit_message>
update project1 and ppt
</commit_message>
<xml_diff>
--- a/2BS5.pptx
+++ b/2BS5.pptx
@@ -222,7 +222,7 @@
           <a:p>
             <a:fld id="{2D9D2B54-8F89-4695-92B9-17EDEF6EA58F}" type="datetimeFigureOut">
               <a:rPr lang="zh-TW" altLang="en-US" smtClean="0"/>
-              <a:t>2025/12/16</a:t>
+              <a:t>2026/3/5</a:t>
             </a:fld>
             <a:endParaRPr lang="zh-TW" altLang="en-US"/>
           </a:p>
@@ -1015,7 +1015,7 @@
           <a:p>
             <a:fld id="{746F9C1A-3528-47D7-9DBD-D23441465755}" type="datetimeFigureOut">
               <a:rPr lang="zh-TW" altLang="en-US" smtClean="0"/>
-              <a:t>2025/12/16</a:t>
+              <a:t>2026/3/5</a:t>
             </a:fld>
             <a:endParaRPr lang="zh-TW" altLang="en-US"/>
           </a:p>
@@ -1213,7 +1213,7 @@
           <a:p>
             <a:fld id="{746F9C1A-3528-47D7-9DBD-D23441465755}" type="datetimeFigureOut">
               <a:rPr lang="zh-TW" altLang="en-US" smtClean="0"/>
-              <a:t>2025/12/16</a:t>
+              <a:t>2026/3/5</a:t>
             </a:fld>
             <a:endParaRPr lang="zh-TW" altLang="en-US"/>
           </a:p>
@@ -1421,7 +1421,7 @@
           <a:p>
             <a:fld id="{746F9C1A-3528-47D7-9DBD-D23441465755}" type="datetimeFigureOut">
               <a:rPr lang="zh-TW" altLang="en-US" smtClean="0"/>
-              <a:t>2025/12/16</a:t>
+              <a:t>2026/3/5</a:t>
             </a:fld>
             <a:endParaRPr lang="zh-TW" altLang="en-US"/>
           </a:p>
@@ -1715,7 +1715,7 @@
           <a:p>
             <a:fld id="{01F2E14E-90DA-4348-BFC3-233F8518E0D1}" type="datetimeFigureOut">
               <a:rPr lang="zh-TW" altLang="en-US" smtClean="0"/>
-              <a:t>2025/12/16</a:t>
+              <a:t>2026/3/5</a:t>
             </a:fld>
             <a:endParaRPr lang="zh-TW" altLang="en-US"/>
           </a:p>
@@ -1980,7 +1980,7 @@
           <a:p>
             <a:fld id="{01F2E14E-90DA-4348-BFC3-233F8518E0D1}" type="datetimeFigureOut">
               <a:rPr lang="zh-TW" altLang="en-US" smtClean="0"/>
-              <a:t>2025/12/16</a:t>
+              <a:t>2026/3/5</a:t>
             </a:fld>
             <a:endParaRPr lang="zh-TW" altLang="en-US"/>
           </a:p>
@@ -2228,7 +2228,7 @@
           <a:p>
             <a:fld id="{01F2E14E-90DA-4348-BFC3-233F8518E0D1}" type="datetimeFigureOut">
               <a:rPr lang="zh-TW" altLang="en-US" smtClean="0"/>
-              <a:t>2025/12/16</a:t>
+              <a:t>2026/3/5</a:t>
             </a:fld>
             <a:endParaRPr lang="zh-TW" altLang="en-US"/>
           </a:p>
@@ -2551,7 +2551,7 @@
           <a:p>
             <a:fld id="{01F2E14E-90DA-4348-BFC3-233F8518E0D1}" type="datetimeFigureOut">
               <a:rPr lang="zh-TW" altLang="en-US" smtClean="0"/>
-              <a:t>2025/12/16</a:t>
+              <a:t>2026/3/5</a:t>
             </a:fld>
             <a:endParaRPr lang="zh-TW" altLang="en-US"/>
           </a:p>
@@ -3022,7 +3022,7 @@
           <a:p>
             <a:fld id="{01F2E14E-90DA-4348-BFC3-233F8518E0D1}" type="datetimeFigureOut">
               <a:rPr lang="zh-TW" altLang="en-US" smtClean="0"/>
-              <a:t>2025/12/16</a:t>
+              <a:t>2026/3/5</a:t>
             </a:fld>
             <a:endParaRPr lang="zh-TW" altLang="en-US"/>
           </a:p>
@@ -3175,7 +3175,7 @@
           <a:p>
             <a:fld id="{01F2E14E-90DA-4348-BFC3-233F8518E0D1}" type="datetimeFigureOut">
               <a:rPr lang="zh-TW" altLang="en-US" smtClean="0"/>
-              <a:t>2025/12/16</a:t>
+              <a:t>2026/3/5</a:t>
             </a:fld>
             <a:endParaRPr lang="zh-TW" altLang="en-US"/>
           </a:p>
@@ -3270,7 +3270,7 @@
           <a:p>
             <a:fld id="{01F2E14E-90DA-4348-BFC3-233F8518E0D1}" type="datetimeFigureOut">
               <a:rPr lang="zh-TW" altLang="en-US" smtClean="0"/>
-              <a:t>2025/12/16</a:t>
+              <a:t>2026/3/5</a:t>
             </a:fld>
             <a:endParaRPr lang="zh-TW" altLang="en-US"/>
           </a:p>
@@ -3549,7 +3549,7 @@
           <a:p>
             <a:fld id="{01F2E14E-90DA-4348-BFC3-233F8518E0D1}" type="datetimeFigureOut">
               <a:rPr lang="zh-TW" altLang="en-US" smtClean="0"/>
-              <a:t>2025/12/16</a:t>
+              <a:t>2026/3/5</a:t>
             </a:fld>
             <a:endParaRPr lang="zh-TW" altLang="en-US"/>
           </a:p>
@@ -3770,7 +3770,7 @@
           <a:p>
             <a:fld id="{746F9C1A-3528-47D7-9DBD-D23441465755}" type="datetimeFigureOut">
               <a:rPr lang="zh-TW" altLang="en-US" smtClean="0"/>
-              <a:t>2025/12/16</a:t>
+              <a:t>2026/3/5</a:t>
             </a:fld>
             <a:endParaRPr lang="zh-TW" altLang="en-US"/>
           </a:p>
@@ -4057,7 +4057,7 @@
           <a:p>
             <a:fld id="{01F2E14E-90DA-4348-BFC3-233F8518E0D1}" type="datetimeFigureOut">
               <a:rPr lang="zh-TW" altLang="en-US" smtClean="0"/>
-              <a:t>2025/12/16</a:t>
+              <a:t>2026/3/5</a:t>
             </a:fld>
             <a:endParaRPr lang="zh-TW" altLang="en-US"/>
           </a:p>
@@ -4227,7 +4227,7 @@
           <a:p>
             <a:fld id="{01F2E14E-90DA-4348-BFC3-233F8518E0D1}" type="datetimeFigureOut">
               <a:rPr lang="zh-TW" altLang="en-US" smtClean="0"/>
-              <a:t>2025/12/16</a:t>
+              <a:t>2026/3/5</a:t>
             </a:fld>
             <a:endParaRPr lang="zh-TW" altLang="en-US"/>
           </a:p>
@@ -4407,7 +4407,7 @@
           <a:p>
             <a:fld id="{01F2E14E-90DA-4348-BFC3-233F8518E0D1}" type="datetimeFigureOut">
               <a:rPr lang="zh-TW" altLang="en-US" smtClean="0"/>
-              <a:t>2025/12/16</a:t>
+              <a:t>2026/3/5</a:t>
             </a:fld>
             <a:endParaRPr lang="zh-TW" altLang="en-US"/>
           </a:p>
@@ -4670,7 +4670,7 @@
           <a:p>
             <a:fld id="{746F9C1A-3528-47D7-9DBD-D23441465755}" type="datetimeFigureOut">
               <a:rPr lang="zh-TW" altLang="en-US" smtClean="0"/>
-              <a:t>2025/12/16</a:t>
+              <a:t>2026/3/5</a:t>
             </a:fld>
             <a:endParaRPr lang="zh-TW" altLang="en-US"/>
           </a:p>
@@ -4935,7 +4935,7 @@
           <a:p>
             <a:fld id="{746F9C1A-3528-47D7-9DBD-D23441465755}" type="datetimeFigureOut">
               <a:rPr lang="zh-TW" altLang="en-US" smtClean="0"/>
-              <a:t>2025/12/16</a:t>
+              <a:t>2026/3/5</a:t>
             </a:fld>
             <a:endParaRPr lang="zh-TW" altLang="en-US"/>
           </a:p>
@@ -5347,7 +5347,7 @@
           <a:p>
             <a:fld id="{746F9C1A-3528-47D7-9DBD-D23441465755}" type="datetimeFigureOut">
               <a:rPr lang="zh-TW" altLang="en-US" smtClean="0"/>
-              <a:t>2025/12/16</a:t>
+              <a:t>2026/3/5</a:t>
             </a:fld>
             <a:endParaRPr lang="zh-TW" altLang="en-US"/>
           </a:p>
@@ -5488,7 +5488,7 @@
           <a:p>
             <a:fld id="{746F9C1A-3528-47D7-9DBD-D23441465755}" type="datetimeFigureOut">
               <a:rPr lang="zh-TW" altLang="en-US" smtClean="0"/>
-              <a:t>2025/12/16</a:t>
+              <a:t>2026/3/5</a:t>
             </a:fld>
             <a:endParaRPr lang="zh-TW" altLang="en-US"/>
           </a:p>
@@ -5601,7 +5601,7 @@
           <a:p>
             <a:fld id="{746F9C1A-3528-47D7-9DBD-D23441465755}" type="datetimeFigureOut">
               <a:rPr lang="zh-TW" altLang="en-US" smtClean="0"/>
-              <a:t>2025/12/16</a:t>
+              <a:t>2026/3/5</a:t>
             </a:fld>
             <a:endParaRPr lang="zh-TW" altLang="en-US"/>
           </a:p>
@@ -5912,7 +5912,7 @@
           <a:p>
             <a:fld id="{746F9C1A-3528-47D7-9DBD-D23441465755}" type="datetimeFigureOut">
               <a:rPr lang="zh-TW" altLang="en-US" smtClean="0"/>
-              <a:t>2025/12/16</a:t>
+              <a:t>2026/3/5</a:t>
             </a:fld>
             <a:endParaRPr lang="zh-TW" altLang="en-US"/>
           </a:p>
@@ -6200,7 +6200,7 @@
           <a:p>
             <a:fld id="{746F9C1A-3528-47D7-9DBD-D23441465755}" type="datetimeFigureOut">
               <a:rPr lang="zh-TW" altLang="en-US" smtClean="0"/>
-              <a:t>2025/12/16</a:t>
+              <a:t>2026/3/5</a:t>
             </a:fld>
             <a:endParaRPr lang="zh-TW" altLang="en-US"/>
           </a:p>
@@ -6441,7 +6441,7 @@
           <a:p>
             <a:fld id="{746F9C1A-3528-47D7-9DBD-D23441465755}" type="datetimeFigureOut">
               <a:rPr lang="zh-TW" altLang="en-US" smtClean="0"/>
-              <a:t>2025/12/16</a:t>
+              <a:t>2026/3/5</a:t>
             </a:fld>
             <a:endParaRPr lang="zh-TW" altLang="en-US"/>
           </a:p>
@@ -7037,7 +7037,7 @@
           <a:p>
             <a:fld id="{01F2E14E-90DA-4348-BFC3-233F8518E0D1}" type="datetimeFigureOut">
               <a:rPr lang="zh-TW" altLang="en-US" smtClean="0"/>
-              <a:t>2025/12/16</a:t>
+              <a:t>2026/3/5</a:t>
             </a:fld>
             <a:endParaRPr lang="zh-TW" altLang="en-US"/>
           </a:p>
@@ -16326,8 +16326,20 @@
           <a:lstStyle/>
           <a:p>
             <a:r>
+              <a:rPr lang="en-US" altLang="zh-TW" dirty="0"/>
+              <a:t>BS</a:t>
+            </a:r>
+            <a:r>
               <a:rPr lang="zh-TW" altLang="en-US" dirty="0"/>
-              <a:t>文字練習 </a:t>
+              <a:t>文字效果</a:t>
+            </a:r>
+            <a:r>
+              <a:rPr lang="en-US" altLang="zh-TW" dirty="0"/>
+              <a:t>-</a:t>
+            </a:r>
+            <a:r>
+              <a:rPr lang="zh-TW" altLang="en-US" dirty="0"/>
+              <a:t>內容樣式 </a:t>
             </a:r>
             <a:r>
               <a:rPr lang="en-US" altLang="zh-TW" dirty="0"/>

</xml_diff>

<commit_message>
update bs5.ppt for convert tool & upload web site
</commit_message>
<xml_diff>
--- a/2BS5.pptx
+++ b/2BS5.pptx
@@ -134,7 +134,7 @@
   </p:defaultTextStyle>
   <p:extLst>
     <p:ext uri="{EFAFB233-063F-42B5-8137-9DF3F51BA10A}">
-      <p15:sldGuideLst xmlns:p15="http://schemas.microsoft.com/office/powerpoint/2012/main"/>
+      <p15:sldGuideLst xmlns:p15="http://schemas.microsoft.com/office/powerpoint/2012/main" xmlns=""/>
     </p:ext>
   </p:extLst>
 </p:presentation>
@@ -222,7 +222,7 @@
           <a:p>
             <a:fld id="{2D9D2B54-8F89-4695-92B9-17EDEF6EA58F}" type="datetimeFigureOut">
               <a:rPr lang="zh-TW" altLang="en-US" smtClean="0"/>
-              <a:t>2026/8/22</a:t>
+              <a:t>2026/8/24</a:t>
             </a:fld>
             <a:endParaRPr lang="zh-TW" altLang="en-US"/>
           </a:p>
@@ -890,7 +890,7 @@
           <p:cNvPr id="2" name="標題 1">
             <a:extLst>
               <a:ext uri="{FF2B5EF4-FFF2-40B4-BE49-F238E27FC236}">
-                <a16:creationId xmlns:a16="http://schemas.microsoft.com/office/drawing/2014/main" id="{C7FCFC8C-5F14-57BB-7368-3A463954DC7C}"/>
+                <a16:creationId xmlns:a16="http://schemas.microsoft.com/office/drawing/2014/main" xmlns="" id="{C7FCFC8C-5F14-57BB-7368-3A463954DC7C}"/>
               </a:ext>
             </a:extLst>
           </p:cNvPr>
@@ -927,7 +927,7 @@
           <p:cNvPr id="3" name="副標題 2">
             <a:extLst>
               <a:ext uri="{FF2B5EF4-FFF2-40B4-BE49-F238E27FC236}">
-                <a16:creationId xmlns:a16="http://schemas.microsoft.com/office/drawing/2014/main" id="{6D6692EE-6B81-2D3E-F685-DE17ED0349EA}"/>
+                <a16:creationId xmlns:a16="http://schemas.microsoft.com/office/drawing/2014/main" xmlns="" id="{6D6692EE-6B81-2D3E-F685-DE17ED0349EA}"/>
               </a:ext>
             </a:extLst>
           </p:cNvPr>
@@ -997,7 +997,7 @@
           <p:cNvPr id="4" name="日期版面配置區 3">
             <a:extLst>
               <a:ext uri="{FF2B5EF4-FFF2-40B4-BE49-F238E27FC236}">
-                <a16:creationId xmlns:a16="http://schemas.microsoft.com/office/drawing/2014/main" id="{4CE64190-A8A3-8688-0545-3503A4564E3F}"/>
+                <a16:creationId xmlns:a16="http://schemas.microsoft.com/office/drawing/2014/main" xmlns="" id="{4CE64190-A8A3-8688-0545-3503A4564E3F}"/>
               </a:ext>
             </a:extLst>
           </p:cNvPr>
@@ -1015,7 +1015,7 @@
           <a:p>
             <a:fld id="{746F9C1A-3528-47D7-9DBD-D23441465755}" type="datetimeFigureOut">
               <a:rPr lang="zh-TW" altLang="en-US" smtClean="0"/>
-              <a:t>2026/8/22</a:t>
+              <a:t>2026/8/24</a:t>
             </a:fld>
             <a:endParaRPr lang="zh-TW" altLang="en-US"/>
           </a:p>
@@ -1026,7 +1026,7 @@
           <p:cNvPr id="5" name="頁尾版面配置區 4">
             <a:extLst>
               <a:ext uri="{FF2B5EF4-FFF2-40B4-BE49-F238E27FC236}">
-                <a16:creationId xmlns:a16="http://schemas.microsoft.com/office/drawing/2014/main" id="{37D8ECF4-5BF1-5F8E-02E5-B5F70B58BCAA}"/>
+                <a16:creationId xmlns:a16="http://schemas.microsoft.com/office/drawing/2014/main" xmlns="" id="{37D8ECF4-5BF1-5F8E-02E5-B5F70B58BCAA}"/>
               </a:ext>
             </a:extLst>
           </p:cNvPr>
@@ -1051,7 +1051,7 @@
           <p:cNvPr id="6" name="投影片編號版面配置區 5">
             <a:extLst>
               <a:ext uri="{FF2B5EF4-FFF2-40B4-BE49-F238E27FC236}">
-                <a16:creationId xmlns:a16="http://schemas.microsoft.com/office/drawing/2014/main" id="{0E40CB68-7A02-F750-18A6-F8D1871C6EBC}"/>
+                <a16:creationId xmlns:a16="http://schemas.microsoft.com/office/drawing/2014/main" xmlns="" id="{0E40CB68-7A02-F750-18A6-F8D1871C6EBC}"/>
               </a:ext>
             </a:extLst>
           </p:cNvPr>
@@ -1110,7 +1110,7 @@
           <p:cNvPr id="2" name="標題 1">
             <a:extLst>
               <a:ext uri="{FF2B5EF4-FFF2-40B4-BE49-F238E27FC236}">
-                <a16:creationId xmlns:a16="http://schemas.microsoft.com/office/drawing/2014/main" id="{9162E1B8-B318-21DF-939E-27F0B990BBFA}"/>
+                <a16:creationId xmlns:a16="http://schemas.microsoft.com/office/drawing/2014/main" xmlns="" id="{9162E1B8-B318-21DF-939E-27F0B990BBFA}"/>
               </a:ext>
             </a:extLst>
           </p:cNvPr>
@@ -1138,7 +1138,7 @@
           <p:cNvPr id="3" name="直排文字版面配置區 2">
             <a:extLst>
               <a:ext uri="{FF2B5EF4-FFF2-40B4-BE49-F238E27FC236}">
-                <a16:creationId xmlns:a16="http://schemas.microsoft.com/office/drawing/2014/main" id="{71B38062-0CE2-15AA-0FED-D1ED4A8BE0CB}"/>
+                <a16:creationId xmlns:a16="http://schemas.microsoft.com/office/drawing/2014/main" xmlns="" id="{71B38062-0CE2-15AA-0FED-D1ED4A8BE0CB}"/>
               </a:ext>
             </a:extLst>
           </p:cNvPr>
@@ -1195,7 +1195,7 @@
           <p:cNvPr id="4" name="日期版面配置區 3">
             <a:extLst>
               <a:ext uri="{FF2B5EF4-FFF2-40B4-BE49-F238E27FC236}">
-                <a16:creationId xmlns:a16="http://schemas.microsoft.com/office/drawing/2014/main" id="{7C0791A7-4745-3C5C-DB34-5243B871B845}"/>
+                <a16:creationId xmlns:a16="http://schemas.microsoft.com/office/drawing/2014/main" xmlns="" id="{7C0791A7-4745-3C5C-DB34-5243B871B845}"/>
               </a:ext>
             </a:extLst>
           </p:cNvPr>
@@ -1213,7 +1213,7 @@
           <a:p>
             <a:fld id="{746F9C1A-3528-47D7-9DBD-D23441465755}" type="datetimeFigureOut">
               <a:rPr lang="zh-TW" altLang="en-US" smtClean="0"/>
-              <a:t>2026/8/22</a:t>
+              <a:t>2026/8/24</a:t>
             </a:fld>
             <a:endParaRPr lang="zh-TW" altLang="en-US"/>
           </a:p>
@@ -1224,7 +1224,7 @@
           <p:cNvPr id="5" name="頁尾版面配置區 4">
             <a:extLst>
               <a:ext uri="{FF2B5EF4-FFF2-40B4-BE49-F238E27FC236}">
-                <a16:creationId xmlns:a16="http://schemas.microsoft.com/office/drawing/2014/main" id="{0FC8CAD7-4A47-3AE3-E3FC-723DF8B83E1F}"/>
+                <a16:creationId xmlns:a16="http://schemas.microsoft.com/office/drawing/2014/main" xmlns="" id="{0FC8CAD7-4A47-3AE3-E3FC-723DF8B83E1F}"/>
               </a:ext>
             </a:extLst>
           </p:cNvPr>
@@ -1249,7 +1249,7 @@
           <p:cNvPr id="6" name="投影片編號版面配置區 5">
             <a:extLst>
               <a:ext uri="{FF2B5EF4-FFF2-40B4-BE49-F238E27FC236}">
-                <a16:creationId xmlns:a16="http://schemas.microsoft.com/office/drawing/2014/main" id="{4C026964-8159-9F48-F0E8-C521F2C9B636}"/>
+                <a16:creationId xmlns:a16="http://schemas.microsoft.com/office/drawing/2014/main" xmlns="" id="{4C026964-8159-9F48-F0E8-C521F2C9B636}"/>
               </a:ext>
             </a:extLst>
           </p:cNvPr>
@@ -1308,7 +1308,7 @@
           <p:cNvPr id="2" name="直排標題 1">
             <a:extLst>
               <a:ext uri="{FF2B5EF4-FFF2-40B4-BE49-F238E27FC236}">
-                <a16:creationId xmlns:a16="http://schemas.microsoft.com/office/drawing/2014/main" id="{FEDBC2DE-FC1C-06C7-431E-589DF98ED9CB}"/>
+                <a16:creationId xmlns:a16="http://schemas.microsoft.com/office/drawing/2014/main" xmlns="" id="{FEDBC2DE-FC1C-06C7-431E-589DF98ED9CB}"/>
               </a:ext>
             </a:extLst>
           </p:cNvPr>
@@ -1341,7 +1341,7 @@
           <p:cNvPr id="3" name="直排文字版面配置區 2">
             <a:extLst>
               <a:ext uri="{FF2B5EF4-FFF2-40B4-BE49-F238E27FC236}">
-                <a16:creationId xmlns:a16="http://schemas.microsoft.com/office/drawing/2014/main" id="{ECE3DEBD-199E-5ED3-144D-9A7CB197AB90}"/>
+                <a16:creationId xmlns:a16="http://schemas.microsoft.com/office/drawing/2014/main" xmlns="" id="{ECE3DEBD-199E-5ED3-144D-9A7CB197AB90}"/>
               </a:ext>
             </a:extLst>
           </p:cNvPr>
@@ -1403,7 +1403,7 @@
           <p:cNvPr id="4" name="日期版面配置區 3">
             <a:extLst>
               <a:ext uri="{FF2B5EF4-FFF2-40B4-BE49-F238E27FC236}">
-                <a16:creationId xmlns:a16="http://schemas.microsoft.com/office/drawing/2014/main" id="{BA82442B-D29E-3881-5B57-FD8D77889D03}"/>
+                <a16:creationId xmlns:a16="http://schemas.microsoft.com/office/drawing/2014/main" xmlns="" id="{BA82442B-D29E-3881-5B57-FD8D77889D03}"/>
               </a:ext>
             </a:extLst>
           </p:cNvPr>
@@ -1421,7 +1421,7 @@
           <a:p>
             <a:fld id="{746F9C1A-3528-47D7-9DBD-D23441465755}" type="datetimeFigureOut">
               <a:rPr lang="zh-TW" altLang="en-US" smtClean="0"/>
-              <a:t>2026/8/22</a:t>
+              <a:t>2026/8/24</a:t>
             </a:fld>
             <a:endParaRPr lang="zh-TW" altLang="en-US"/>
           </a:p>
@@ -1432,7 +1432,7 @@
           <p:cNvPr id="5" name="頁尾版面配置區 4">
             <a:extLst>
               <a:ext uri="{FF2B5EF4-FFF2-40B4-BE49-F238E27FC236}">
-                <a16:creationId xmlns:a16="http://schemas.microsoft.com/office/drawing/2014/main" id="{BE6DA4B6-8247-B50C-B4D7-583438B1418C}"/>
+                <a16:creationId xmlns:a16="http://schemas.microsoft.com/office/drawing/2014/main" xmlns="" id="{BE6DA4B6-8247-B50C-B4D7-583438B1418C}"/>
               </a:ext>
             </a:extLst>
           </p:cNvPr>
@@ -1457,7 +1457,7 @@
           <p:cNvPr id="6" name="投影片編號版面配置區 5">
             <a:extLst>
               <a:ext uri="{FF2B5EF4-FFF2-40B4-BE49-F238E27FC236}">
-                <a16:creationId xmlns:a16="http://schemas.microsoft.com/office/drawing/2014/main" id="{16601FC3-E851-AC85-3B56-C5F910CE3AD9}"/>
+                <a16:creationId xmlns:a16="http://schemas.microsoft.com/office/drawing/2014/main" xmlns="" id="{16601FC3-E851-AC85-3B56-C5F910CE3AD9}"/>
               </a:ext>
             </a:extLst>
           </p:cNvPr>
@@ -1516,7 +1516,7 @@
           <p:cNvPr id="13" name="圖片 12">
             <a:extLst>
               <a:ext uri="{FF2B5EF4-FFF2-40B4-BE49-F238E27FC236}">
-                <a16:creationId xmlns:a16="http://schemas.microsoft.com/office/drawing/2014/main" id="{F8FAA2ED-CE8C-4CA4-92E3-E2C5E084078A}"/>
+                <a16:creationId xmlns:a16="http://schemas.microsoft.com/office/drawing/2014/main" xmlns="" id="{F8FAA2ED-CE8C-4CA4-92E3-E2C5E084078A}"/>
               </a:ext>
             </a:extLst>
           </p:cNvPr>
@@ -1715,7 +1715,7 @@
           <a:p>
             <a:fld id="{01F2E14E-90DA-4348-BFC3-233F8518E0D1}" type="datetimeFigureOut">
               <a:rPr lang="zh-TW" altLang="en-US" smtClean="0"/>
-              <a:t>2026/8/22</a:t>
+              <a:t>2026/8/24</a:t>
             </a:fld>
             <a:endParaRPr lang="zh-TW" altLang="en-US"/>
           </a:p>
@@ -1805,7 +1805,7 @@
           <p:cNvPr id="12" name="圖片 11">
             <a:extLst>
               <a:ext uri="{FF2B5EF4-FFF2-40B4-BE49-F238E27FC236}">
-                <a16:creationId xmlns:a16="http://schemas.microsoft.com/office/drawing/2014/main" id="{1F10841E-58C4-40F5-AB87-66E5F3AFB556}"/>
+                <a16:creationId xmlns:a16="http://schemas.microsoft.com/office/drawing/2014/main" xmlns="" id="{1F10841E-58C4-40F5-AB87-66E5F3AFB556}"/>
               </a:ext>
             </a:extLst>
           </p:cNvPr>
@@ -1834,7 +1834,7 @@
           <p:cNvPr id="14" name="圖片 13">
             <a:extLst>
               <a:ext uri="{FF2B5EF4-FFF2-40B4-BE49-F238E27FC236}">
-                <a16:creationId xmlns:a16="http://schemas.microsoft.com/office/drawing/2014/main" id="{96C13D81-E70D-4CE7-B6CC-32FCA0D44A39}"/>
+                <a16:creationId xmlns:a16="http://schemas.microsoft.com/office/drawing/2014/main" xmlns="" id="{96C13D81-E70D-4CE7-B6CC-32FCA0D44A39}"/>
               </a:ext>
             </a:extLst>
           </p:cNvPr>
@@ -1980,7 +1980,7 @@
           <a:p>
             <a:fld id="{01F2E14E-90DA-4348-BFC3-233F8518E0D1}" type="datetimeFigureOut">
               <a:rPr lang="zh-TW" altLang="en-US" smtClean="0"/>
-              <a:t>2026/8/22</a:t>
+              <a:t>2026/8/24</a:t>
             </a:fld>
             <a:endParaRPr lang="zh-TW" altLang="en-US"/>
           </a:p>
@@ -2228,7 +2228,7 @@
           <a:p>
             <a:fld id="{01F2E14E-90DA-4348-BFC3-233F8518E0D1}" type="datetimeFigureOut">
               <a:rPr lang="zh-TW" altLang="en-US" smtClean="0"/>
-              <a:t>2026/8/22</a:t>
+              <a:t>2026/8/24</a:t>
             </a:fld>
             <a:endParaRPr lang="zh-TW" altLang="en-US"/>
           </a:p>
@@ -2551,7 +2551,7 @@
           <a:p>
             <a:fld id="{01F2E14E-90DA-4348-BFC3-233F8518E0D1}" type="datetimeFigureOut">
               <a:rPr lang="zh-TW" altLang="en-US" smtClean="0"/>
-              <a:t>2026/8/22</a:t>
+              <a:t>2026/8/24</a:t>
             </a:fld>
             <a:endParaRPr lang="zh-TW" altLang="en-US"/>
           </a:p>
@@ -3022,7 +3022,7 @@
           <a:p>
             <a:fld id="{01F2E14E-90DA-4348-BFC3-233F8518E0D1}" type="datetimeFigureOut">
               <a:rPr lang="zh-TW" altLang="en-US" smtClean="0"/>
-              <a:t>2026/8/22</a:t>
+              <a:t>2026/8/24</a:t>
             </a:fld>
             <a:endParaRPr lang="zh-TW" altLang="en-US"/>
           </a:p>
@@ -3175,7 +3175,7 @@
           <a:p>
             <a:fld id="{01F2E14E-90DA-4348-BFC3-233F8518E0D1}" type="datetimeFigureOut">
               <a:rPr lang="zh-TW" altLang="en-US" smtClean="0"/>
-              <a:t>2026/8/22</a:t>
+              <a:t>2026/8/24</a:t>
             </a:fld>
             <a:endParaRPr lang="zh-TW" altLang="en-US"/>
           </a:p>
@@ -3270,7 +3270,7 @@
           <a:p>
             <a:fld id="{01F2E14E-90DA-4348-BFC3-233F8518E0D1}" type="datetimeFigureOut">
               <a:rPr lang="zh-TW" altLang="en-US" smtClean="0"/>
-              <a:t>2026/8/22</a:t>
+              <a:t>2026/8/24</a:t>
             </a:fld>
             <a:endParaRPr lang="zh-TW" altLang="en-US"/>
           </a:p>
@@ -3549,7 +3549,7 @@
           <a:p>
             <a:fld id="{01F2E14E-90DA-4348-BFC3-233F8518E0D1}" type="datetimeFigureOut">
               <a:rPr lang="zh-TW" altLang="en-US" smtClean="0"/>
-              <a:t>2026/8/22</a:t>
+              <a:t>2026/8/24</a:t>
             </a:fld>
             <a:endParaRPr lang="zh-TW" altLang="en-US"/>
           </a:p>
@@ -3667,7 +3667,7 @@
           <p:cNvPr id="2" name="標題 1">
             <a:extLst>
               <a:ext uri="{FF2B5EF4-FFF2-40B4-BE49-F238E27FC236}">
-                <a16:creationId xmlns:a16="http://schemas.microsoft.com/office/drawing/2014/main" id="{6EB99AE4-7616-B99F-6403-520FA01C71B3}"/>
+                <a16:creationId xmlns:a16="http://schemas.microsoft.com/office/drawing/2014/main" xmlns="" id="{6EB99AE4-7616-B99F-6403-520FA01C71B3}"/>
               </a:ext>
             </a:extLst>
           </p:cNvPr>
@@ -3695,7 +3695,7 @@
           <p:cNvPr id="3" name="內容版面配置區 2">
             <a:extLst>
               <a:ext uri="{FF2B5EF4-FFF2-40B4-BE49-F238E27FC236}">
-                <a16:creationId xmlns:a16="http://schemas.microsoft.com/office/drawing/2014/main" id="{EB93C9F2-BE20-9320-B30C-4516966A8D16}"/>
+                <a16:creationId xmlns:a16="http://schemas.microsoft.com/office/drawing/2014/main" xmlns="" id="{EB93C9F2-BE20-9320-B30C-4516966A8D16}"/>
               </a:ext>
             </a:extLst>
           </p:cNvPr>
@@ -3752,7 +3752,7 @@
           <p:cNvPr id="4" name="日期版面配置區 3">
             <a:extLst>
               <a:ext uri="{FF2B5EF4-FFF2-40B4-BE49-F238E27FC236}">
-                <a16:creationId xmlns:a16="http://schemas.microsoft.com/office/drawing/2014/main" id="{AE2B5BE6-C502-2715-53BE-223663AB0DA8}"/>
+                <a16:creationId xmlns:a16="http://schemas.microsoft.com/office/drawing/2014/main" xmlns="" id="{AE2B5BE6-C502-2715-53BE-223663AB0DA8}"/>
               </a:ext>
             </a:extLst>
           </p:cNvPr>
@@ -3770,7 +3770,7 @@
           <a:p>
             <a:fld id="{746F9C1A-3528-47D7-9DBD-D23441465755}" type="datetimeFigureOut">
               <a:rPr lang="zh-TW" altLang="en-US" smtClean="0"/>
-              <a:t>2026/8/22</a:t>
+              <a:t>2026/8/24</a:t>
             </a:fld>
             <a:endParaRPr lang="zh-TW" altLang="en-US"/>
           </a:p>
@@ -3781,7 +3781,7 @@
           <p:cNvPr id="5" name="頁尾版面配置區 4">
             <a:extLst>
               <a:ext uri="{FF2B5EF4-FFF2-40B4-BE49-F238E27FC236}">
-                <a16:creationId xmlns:a16="http://schemas.microsoft.com/office/drawing/2014/main" id="{9D7B6E2C-9EAF-9021-C6D8-937369D94508}"/>
+                <a16:creationId xmlns:a16="http://schemas.microsoft.com/office/drawing/2014/main" xmlns="" id="{9D7B6E2C-9EAF-9021-C6D8-937369D94508}"/>
               </a:ext>
             </a:extLst>
           </p:cNvPr>
@@ -3806,7 +3806,7 @@
           <p:cNvPr id="6" name="投影片編號版面配置區 5">
             <a:extLst>
               <a:ext uri="{FF2B5EF4-FFF2-40B4-BE49-F238E27FC236}">
-                <a16:creationId xmlns:a16="http://schemas.microsoft.com/office/drawing/2014/main" id="{0AF9EEA3-83BA-B614-BD7B-2DD11D24CFB4}"/>
+                <a16:creationId xmlns:a16="http://schemas.microsoft.com/office/drawing/2014/main" xmlns="" id="{0AF9EEA3-83BA-B614-BD7B-2DD11D24CFB4}"/>
               </a:ext>
             </a:extLst>
           </p:cNvPr>
@@ -4057,7 +4057,7 @@
           <a:p>
             <a:fld id="{01F2E14E-90DA-4348-BFC3-233F8518E0D1}" type="datetimeFigureOut">
               <a:rPr lang="zh-TW" altLang="en-US" smtClean="0"/>
-              <a:t>2026/8/22</a:t>
+              <a:t>2026/8/24</a:t>
             </a:fld>
             <a:endParaRPr lang="zh-TW" altLang="en-US"/>
           </a:p>
@@ -4227,7 +4227,7 @@
           <a:p>
             <a:fld id="{01F2E14E-90DA-4348-BFC3-233F8518E0D1}" type="datetimeFigureOut">
               <a:rPr lang="zh-TW" altLang="en-US" smtClean="0"/>
-              <a:t>2026/8/22</a:t>
+              <a:t>2026/8/24</a:t>
             </a:fld>
             <a:endParaRPr lang="zh-TW" altLang="en-US"/>
           </a:p>
@@ -4407,7 +4407,7 @@
           <a:p>
             <a:fld id="{01F2E14E-90DA-4348-BFC3-233F8518E0D1}" type="datetimeFigureOut">
               <a:rPr lang="zh-TW" altLang="en-US" smtClean="0"/>
-              <a:t>2026/8/22</a:t>
+              <a:t>2026/8/24</a:t>
             </a:fld>
             <a:endParaRPr lang="zh-TW" altLang="en-US"/>
           </a:p>
@@ -4490,7 +4490,7 @@
           <p:cNvPr id="2" name="標題 1">
             <a:extLst>
               <a:ext uri="{FF2B5EF4-FFF2-40B4-BE49-F238E27FC236}">
-                <a16:creationId xmlns:a16="http://schemas.microsoft.com/office/drawing/2014/main" id="{C7E8130B-CAD5-62B9-49BA-14DEF098EEC9}"/>
+                <a16:creationId xmlns:a16="http://schemas.microsoft.com/office/drawing/2014/main" xmlns="" id="{C7E8130B-CAD5-62B9-49BA-14DEF098EEC9}"/>
               </a:ext>
             </a:extLst>
           </p:cNvPr>
@@ -4527,7 +4527,7 @@
           <p:cNvPr id="3" name="文字版面配置區 2">
             <a:extLst>
               <a:ext uri="{FF2B5EF4-FFF2-40B4-BE49-F238E27FC236}">
-                <a16:creationId xmlns:a16="http://schemas.microsoft.com/office/drawing/2014/main" id="{859E98DF-9506-87DA-4876-09CD0CECEE78}"/>
+                <a16:creationId xmlns:a16="http://schemas.microsoft.com/office/drawing/2014/main" xmlns="" id="{859E98DF-9506-87DA-4876-09CD0CECEE78}"/>
               </a:ext>
             </a:extLst>
           </p:cNvPr>
@@ -4652,7 +4652,7 @@
           <p:cNvPr id="4" name="日期版面配置區 3">
             <a:extLst>
               <a:ext uri="{FF2B5EF4-FFF2-40B4-BE49-F238E27FC236}">
-                <a16:creationId xmlns:a16="http://schemas.microsoft.com/office/drawing/2014/main" id="{AB8E142B-5D9E-0FAF-50F3-81DF03EEF3DE}"/>
+                <a16:creationId xmlns:a16="http://schemas.microsoft.com/office/drawing/2014/main" xmlns="" id="{AB8E142B-5D9E-0FAF-50F3-81DF03EEF3DE}"/>
               </a:ext>
             </a:extLst>
           </p:cNvPr>
@@ -4670,7 +4670,7 @@
           <a:p>
             <a:fld id="{746F9C1A-3528-47D7-9DBD-D23441465755}" type="datetimeFigureOut">
               <a:rPr lang="zh-TW" altLang="en-US" smtClean="0"/>
-              <a:t>2026/8/22</a:t>
+              <a:t>2026/8/24</a:t>
             </a:fld>
             <a:endParaRPr lang="zh-TW" altLang="en-US"/>
           </a:p>
@@ -4681,7 +4681,7 @@
           <p:cNvPr id="5" name="頁尾版面配置區 4">
             <a:extLst>
               <a:ext uri="{FF2B5EF4-FFF2-40B4-BE49-F238E27FC236}">
-                <a16:creationId xmlns:a16="http://schemas.microsoft.com/office/drawing/2014/main" id="{1F9BA85E-67D7-5ADC-2035-CFEC2A40573F}"/>
+                <a16:creationId xmlns:a16="http://schemas.microsoft.com/office/drawing/2014/main" xmlns="" id="{1F9BA85E-67D7-5ADC-2035-CFEC2A40573F}"/>
               </a:ext>
             </a:extLst>
           </p:cNvPr>
@@ -4706,7 +4706,7 @@
           <p:cNvPr id="6" name="投影片編號版面配置區 5">
             <a:extLst>
               <a:ext uri="{FF2B5EF4-FFF2-40B4-BE49-F238E27FC236}">
-                <a16:creationId xmlns:a16="http://schemas.microsoft.com/office/drawing/2014/main" id="{F00E07C6-DC11-FCB7-9B9D-6368E14667D4}"/>
+                <a16:creationId xmlns:a16="http://schemas.microsoft.com/office/drawing/2014/main" xmlns="" id="{F00E07C6-DC11-FCB7-9B9D-6368E14667D4}"/>
               </a:ext>
             </a:extLst>
           </p:cNvPr>
@@ -4765,7 +4765,7 @@
           <p:cNvPr id="2" name="標題 1">
             <a:extLst>
               <a:ext uri="{FF2B5EF4-FFF2-40B4-BE49-F238E27FC236}">
-                <a16:creationId xmlns:a16="http://schemas.microsoft.com/office/drawing/2014/main" id="{326ACDDD-7A6E-B381-FDAA-36547E561DD9}"/>
+                <a16:creationId xmlns:a16="http://schemas.microsoft.com/office/drawing/2014/main" xmlns="" id="{326ACDDD-7A6E-B381-FDAA-36547E561DD9}"/>
               </a:ext>
             </a:extLst>
           </p:cNvPr>
@@ -4793,7 +4793,7 @@
           <p:cNvPr id="3" name="內容版面配置區 2">
             <a:extLst>
               <a:ext uri="{FF2B5EF4-FFF2-40B4-BE49-F238E27FC236}">
-                <a16:creationId xmlns:a16="http://schemas.microsoft.com/office/drawing/2014/main" id="{9F552F32-F3A3-DEAD-ADE5-731394F8685C}"/>
+                <a16:creationId xmlns:a16="http://schemas.microsoft.com/office/drawing/2014/main" xmlns="" id="{9F552F32-F3A3-DEAD-ADE5-731394F8685C}"/>
               </a:ext>
             </a:extLst>
           </p:cNvPr>
@@ -4855,7 +4855,7 @@
           <p:cNvPr id="4" name="內容版面配置區 3">
             <a:extLst>
               <a:ext uri="{FF2B5EF4-FFF2-40B4-BE49-F238E27FC236}">
-                <a16:creationId xmlns:a16="http://schemas.microsoft.com/office/drawing/2014/main" id="{5A3305D1-54C9-991E-8753-028E31C10D98}"/>
+                <a16:creationId xmlns:a16="http://schemas.microsoft.com/office/drawing/2014/main" xmlns="" id="{5A3305D1-54C9-991E-8753-028E31C10D98}"/>
               </a:ext>
             </a:extLst>
           </p:cNvPr>
@@ -4917,7 +4917,7 @@
           <p:cNvPr id="5" name="日期版面配置區 4">
             <a:extLst>
               <a:ext uri="{FF2B5EF4-FFF2-40B4-BE49-F238E27FC236}">
-                <a16:creationId xmlns:a16="http://schemas.microsoft.com/office/drawing/2014/main" id="{A518BD78-F473-BAE6-89C5-19F4A23083DB}"/>
+                <a16:creationId xmlns:a16="http://schemas.microsoft.com/office/drawing/2014/main" xmlns="" id="{A518BD78-F473-BAE6-89C5-19F4A23083DB}"/>
               </a:ext>
             </a:extLst>
           </p:cNvPr>
@@ -4935,7 +4935,7 @@
           <a:p>
             <a:fld id="{746F9C1A-3528-47D7-9DBD-D23441465755}" type="datetimeFigureOut">
               <a:rPr lang="zh-TW" altLang="en-US" smtClean="0"/>
-              <a:t>2026/8/22</a:t>
+              <a:t>2026/8/24</a:t>
             </a:fld>
             <a:endParaRPr lang="zh-TW" altLang="en-US"/>
           </a:p>
@@ -4946,7 +4946,7 @@
           <p:cNvPr id="6" name="頁尾版面配置區 5">
             <a:extLst>
               <a:ext uri="{FF2B5EF4-FFF2-40B4-BE49-F238E27FC236}">
-                <a16:creationId xmlns:a16="http://schemas.microsoft.com/office/drawing/2014/main" id="{F69D9C37-D012-5317-C3F4-0831BA5BFAD6}"/>
+                <a16:creationId xmlns:a16="http://schemas.microsoft.com/office/drawing/2014/main" xmlns="" id="{F69D9C37-D012-5317-C3F4-0831BA5BFAD6}"/>
               </a:ext>
             </a:extLst>
           </p:cNvPr>
@@ -4971,7 +4971,7 @@
           <p:cNvPr id="7" name="投影片編號版面配置區 6">
             <a:extLst>
               <a:ext uri="{FF2B5EF4-FFF2-40B4-BE49-F238E27FC236}">
-                <a16:creationId xmlns:a16="http://schemas.microsoft.com/office/drawing/2014/main" id="{5DF8D82F-597D-6788-5BC6-CB9C10425042}"/>
+                <a16:creationId xmlns:a16="http://schemas.microsoft.com/office/drawing/2014/main" xmlns="" id="{5DF8D82F-597D-6788-5BC6-CB9C10425042}"/>
               </a:ext>
             </a:extLst>
           </p:cNvPr>
@@ -5030,7 +5030,7 @@
           <p:cNvPr id="2" name="標題 1">
             <a:extLst>
               <a:ext uri="{FF2B5EF4-FFF2-40B4-BE49-F238E27FC236}">
-                <a16:creationId xmlns:a16="http://schemas.microsoft.com/office/drawing/2014/main" id="{D1D3F384-0A52-3653-68B0-7B7CF2A8022A}"/>
+                <a16:creationId xmlns:a16="http://schemas.microsoft.com/office/drawing/2014/main" xmlns="" id="{D1D3F384-0A52-3653-68B0-7B7CF2A8022A}"/>
               </a:ext>
             </a:extLst>
           </p:cNvPr>
@@ -5063,7 +5063,7 @@
           <p:cNvPr id="3" name="文字版面配置區 2">
             <a:extLst>
               <a:ext uri="{FF2B5EF4-FFF2-40B4-BE49-F238E27FC236}">
-                <a16:creationId xmlns:a16="http://schemas.microsoft.com/office/drawing/2014/main" id="{95262DF5-BA09-270A-2205-BC08B6588D89}"/>
+                <a16:creationId xmlns:a16="http://schemas.microsoft.com/office/drawing/2014/main" xmlns="" id="{95262DF5-BA09-270A-2205-BC08B6588D89}"/>
               </a:ext>
             </a:extLst>
           </p:cNvPr>
@@ -5134,7 +5134,7 @@
           <p:cNvPr id="4" name="內容版面配置區 3">
             <a:extLst>
               <a:ext uri="{FF2B5EF4-FFF2-40B4-BE49-F238E27FC236}">
-                <a16:creationId xmlns:a16="http://schemas.microsoft.com/office/drawing/2014/main" id="{AC28270E-51B1-831A-7E4A-53E6A51126C1}"/>
+                <a16:creationId xmlns:a16="http://schemas.microsoft.com/office/drawing/2014/main" xmlns="" id="{AC28270E-51B1-831A-7E4A-53E6A51126C1}"/>
               </a:ext>
             </a:extLst>
           </p:cNvPr>
@@ -5196,7 +5196,7 @@
           <p:cNvPr id="5" name="文字版面配置區 4">
             <a:extLst>
               <a:ext uri="{FF2B5EF4-FFF2-40B4-BE49-F238E27FC236}">
-                <a16:creationId xmlns:a16="http://schemas.microsoft.com/office/drawing/2014/main" id="{BBB8AEB4-A130-6981-A3CF-D8A8EE2481E5}"/>
+                <a16:creationId xmlns:a16="http://schemas.microsoft.com/office/drawing/2014/main" xmlns="" id="{BBB8AEB4-A130-6981-A3CF-D8A8EE2481E5}"/>
               </a:ext>
             </a:extLst>
           </p:cNvPr>
@@ -5267,7 +5267,7 @@
           <p:cNvPr id="6" name="內容版面配置區 5">
             <a:extLst>
               <a:ext uri="{FF2B5EF4-FFF2-40B4-BE49-F238E27FC236}">
-                <a16:creationId xmlns:a16="http://schemas.microsoft.com/office/drawing/2014/main" id="{99361C4C-9B12-B78D-3959-B82E717AE71C}"/>
+                <a16:creationId xmlns:a16="http://schemas.microsoft.com/office/drawing/2014/main" xmlns="" id="{99361C4C-9B12-B78D-3959-B82E717AE71C}"/>
               </a:ext>
             </a:extLst>
           </p:cNvPr>
@@ -5329,7 +5329,7 @@
           <p:cNvPr id="7" name="日期版面配置區 6">
             <a:extLst>
               <a:ext uri="{FF2B5EF4-FFF2-40B4-BE49-F238E27FC236}">
-                <a16:creationId xmlns:a16="http://schemas.microsoft.com/office/drawing/2014/main" id="{F2A332D8-45AF-FE5E-E034-8F619F99DB40}"/>
+                <a16:creationId xmlns:a16="http://schemas.microsoft.com/office/drawing/2014/main" xmlns="" id="{F2A332D8-45AF-FE5E-E034-8F619F99DB40}"/>
               </a:ext>
             </a:extLst>
           </p:cNvPr>
@@ -5347,7 +5347,7 @@
           <a:p>
             <a:fld id="{746F9C1A-3528-47D7-9DBD-D23441465755}" type="datetimeFigureOut">
               <a:rPr lang="zh-TW" altLang="en-US" smtClean="0"/>
-              <a:t>2026/8/22</a:t>
+              <a:t>2026/8/24</a:t>
             </a:fld>
             <a:endParaRPr lang="zh-TW" altLang="en-US"/>
           </a:p>
@@ -5358,7 +5358,7 @@
           <p:cNvPr id="8" name="頁尾版面配置區 7">
             <a:extLst>
               <a:ext uri="{FF2B5EF4-FFF2-40B4-BE49-F238E27FC236}">
-                <a16:creationId xmlns:a16="http://schemas.microsoft.com/office/drawing/2014/main" id="{A4D0BB3F-7B63-FBF2-7F33-8302CF57B226}"/>
+                <a16:creationId xmlns:a16="http://schemas.microsoft.com/office/drawing/2014/main" xmlns="" id="{A4D0BB3F-7B63-FBF2-7F33-8302CF57B226}"/>
               </a:ext>
             </a:extLst>
           </p:cNvPr>
@@ -5383,7 +5383,7 @@
           <p:cNvPr id="9" name="投影片編號版面配置區 8">
             <a:extLst>
               <a:ext uri="{FF2B5EF4-FFF2-40B4-BE49-F238E27FC236}">
-                <a16:creationId xmlns:a16="http://schemas.microsoft.com/office/drawing/2014/main" id="{300D9E3E-A886-9FE1-3454-C526B0CD6F73}"/>
+                <a16:creationId xmlns:a16="http://schemas.microsoft.com/office/drawing/2014/main" xmlns="" id="{300D9E3E-A886-9FE1-3454-C526B0CD6F73}"/>
               </a:ext>
             </a:extLst>
           </p:cNvPr>
@@ -5442,7 +5442,7 @@
           <p:cNvPr id="2" name="標題 1">
             <a:extLst>
               <a:ext uri="{FF2B5EF4-FFF2-40B4-BE49-F238E27FC236}">
-                <a16:creationId xmlns:a16="http://schemas.microsoft.com/office/drawing/2014/main" id="{37E8CC2A-7FD7-0685-E11E-0127991FD30F}"/>
+                <a16:creationId xmlns:a16="http://schemas.microsoft.com/office/drawing/2014/main" xmlns="" id="{37E8CC2A-7FD7-0685-E11E-0127991FD30F}"/>
               </a:ext>
             </a:extLst>
           </p:cNvPr>
@@ -5470,7 +5470,7 @@
           <p:cNvPr id="3" name="日期版面配置區 2">
             <a:extLst>
               <a:ext uri="{FF2B5EF4-FFF2-40B4-BE49-F238E27FC236}">
-                <a16:creationId xmlns:a16="http://schemas.microsoft.com/office/drawing/2014/main" id="{3B7DD0F3-7819-EF79-3719-C40AD94AF237}"/>
+                <a16:creationId xmlns:a16="http://schemas.microsoft.com/office/drawing/2014/main" xmlns="" id="{3B7DD0F3-7819-EF79-3719-C40AD94AF237}"/>
               </a:ext>
             </a:extLst>
           </p:cNvPr>
@@ -5488,7 +5488,7 @@
           <a:p>
             <a:fld id="{746F9C1A-3528-47D7-9DBD-D23441465755}" type="datetimeFigureOut">
               <a:rPr lang="zh-TW" altLang="en-US" smtClean="0"/>
-              <a:t>2026/8/22</a:t>
+              <a:t>2026/8/24</a:t>
             </a:fld>
             <a:endParaRPr lang="zh-TW" altLang="en-US"/>
           </a:p>
@@ -5499,7 +5499,7 @@
           <p:cNvPr id="4" name="頁尾版面配置區 3">
             <a:extLst>
               <a:ext uri="{FF2B5EF4-FFF2-40B4-BE49-F238E27FC236}">
-                <a16:creationId xmlns:a16="http://schemas.microsoft.com/office/drawing/2014/main" id="{0EF50596-F800-1FFA-4416-7B369459CB98}"/>
+                <a16:creationId xmlns:a16="http://schemas.microsoft.com/office/drawing/2014/main" xmlns="" id="{0EF50596-F800-1FFA-4416-7B369459CB98}"/>
               </a:ext>
             </a:extLst>
           </p:cNvPr>
@@ -5524,7 +5524,7 @@
           <p:cNvPr id="5" name="投影片編號版面配置區 4">
             <a:extLst>
               <a:ext uri="{FF2B5EF4-FFF2-40B4-BE49-F238E27FC236}">
-                <a16:creationId xmlns:a16="http://schemas.microsoft.com/office/drawing/2014/main" id="{82EDD0C5-2C04-7ED5-7F90-73086BC8C971}"/>
+                <a16:creationId xmlns:a16="http://schemas.microsoft.com/office/drawing/2014/main" xmlns="" id="{82EDD0C5-2C04-7ED5-7F90-73086BC8C971}"/>
               </a:ext>
             </a:extLst>
           </p:cNvPr>
@@ -5583,7 +5583,7 @@
           <p:cNvPr id="2" name="日期版面配置區 1">
             <a:extLst>
               <a:ext uri="{FF2B5EF4-FFF2-40B4-BE49-F238E27FC236}">
-                <a16:creationId xmlns:a16="http://schemas.microsoft.com/office/drawing/2014/main" id="{DB21F50A-D5B7-CDA3-6D54-904EFF869B20}"/>
+                <a16:creationId xmlns:a16="http://schemas.microsoft.com/office/drawing/2014/main" xmlns="" id="{DB21F50A-D5B7-CDA3-6D54-904EFF869B20}"/>
               </a:ext>
             </a:extLst>
           </p:cNvPr>
@@ -5601,7 +5601,7 @@
           <a:p>
             <a:fld id="{746F9C1A-3528-47D7-9DBD-D23441465755}" type="datetimeFigureOut">
               <a:rPr lang="zh-TW" altLang="en-US" smtClean="0"/>
-              <a:t>2026/8/22</a:t>
+              <a:t>2026/8/24</a:t>
             </a:fld>
             <a:endParaRPr lang="zh-TW" altLang="en-US"/>
           </a:p>
@@ -5612,7 +5612,7 @@
           <p:cNvPr id="3" name="頁尾版面配置區 2">
             <a:extLst>
               <a:ext uri="{FF2B5EF4-FFF2-40B4-BE49-F238E27FC236}">
-                <a16:creationId xmlns:a16="http://schemas.microsoft.com/office/drawing/2014/main" id="{FF742879-7AB8-FCED-ACF1-F944327D8A09}"/>
+                <a16:creationId xmlns:a16="http://schemas.microsoft.com/office/drawing/2014/main" xmlns="" id="{FF742879-7AB8-FCED-ACF1-F944327D8A09}"/>
               </a:ext>
             </a:extLst>
           </p:cNvPr>
@@ -5637,7 +5637,7 @@
           <p:cNvPr id="4" name="投影片編號版面配置區 3">
             <a:extLst>
               <a:ext uri="{FF2B5EF4-FFF2-40B4-BE49-F238E27FC236}">
-                <a16:creationId xmlns:a16="http://schemas.microsoft.com/office/drawing/2014/main" id="{F8D92E9D-B1CA-3B06-31DD-C22D26582278}"/>
+                <a16:creationId xmlns:a16="http://schemas.microsoft.com/office/drawing/2014/main" xmlns="" id="{F8D92E9D-B1CA-3B06-31DD-C22D26582278}"/>
               </a:ext>
             </a:extLst>
           </p:cNvPr>
@@ -5696,7 +5696,7 @@
           <p:cNvPr id="2" name="標題 1">
             <a:extLst>
               <a:ext uri="{FF2B5EF4-FFF2-40B4-BE49-F238E27FC236}">
-                <a16:creationId xmlns:a16="http://schemas.microsoft.com/office/drawing/2014/main" id="{2112F4A1-AFCA-565D-CA00-1AB8EAF66A83}"/>
+                <a16:creationId xmlns:a16="http://schemas.microsoft.com/office/drawing/2014/main" xmlns="" id="{2112F4A1-AFCA-565D-CA00-1AB8EAF66A83}"/>
               </a:ext>
             </a:extLst>
           </p:cNvPr>
@@ -5733,7 +5733,7 @@
           <p:cNvPr id="3" name="內容版面配置區 2">
             <a:extLst>
               <a:ext uri="{FF2B5EF4-FFF2-40B4-BE49-F238E27FC236}">
-                <a16:creationId xmlns:a16="http://schemas.microsoft.com/office/drawing/2014/main" id="{449255D1-57AA-F357-4558-F31CA829CAF4}"/>
+                <a16:creationId xmlns:a16="http://schemas.microsoft.com/office/drawing/2014/main" xmlns="" id="{449255D1-57AA-F357-4558-F31CA829CAF4}"/>
               </a:ext>
             </a:extLst>
           </p:cNvPr>
@@ -5823,7 +5823,7 @@
           <p:cNvPr id="4" name="文字版面配置區 3">
             <a:extLst>
               <a:ext uri="{FF2B5EF4-FFF2-40B4-BE49-F238E27FC236}">
-                <a16:creationId xmlns:a16="http://schemas.microsoft.com/office/drawing/2014/main" id="{65BCA011-0155-6BD7-AD18-13AD86D12802}"/>
+                <a16:creationId xmlns:a16="http://schemas.microsoft.com/office/drawing/2014/main" xmlns="" id="{65BCA011-0155-6BD7-AD18-13AD86D12802}"/>
               </a:ext>
             </a:extLst>
           </p:cNvPr>
@@ -5894,7 +5894,7 @@
           <p:cNvPr id="5" name="日期版面配置區 4">
             <a:extLst>
               <a:ext uri="{FF2B5EF4-FFF2-40B4-BE49-F238E27FC236}">
-                <a16:creationId xmlns:a16="http://schemas.microsoft.com/office/drawing/2014/main" id="{2CECD164-1E56-C904-479B-5E9B41D6BFA9}"/>
+                <a16:creationId xmlns:a16="http://schemas.microsoft.com/office/drawing/2014/main" xmlns="" id="{2CECD164-1E56-C904-479B-5E9B41D6BFA9}"/>
               </a:ext>
             </a:extLst>
           </p:cNvPr>
@@ -5912,7 +5912,7 @@
           <a:p>
             <a:fld id="{746F9C1A-3528-47D7-9DBD-D23441465755}" type="datetimeFigureOut">
               <a:rPr lang="zh-TW" altLang="en-US" smtClean="0"/>
-              <a:t>2026/8/22</a:t>
+              <a:t>2026/8/24</a:t>
             </a:fld>
             <a:endParaRPr lang="zh-TW" altLang="en-US"/>
           </a:p>
@@ -5923,7 +5923,7 @@
           <p:cNvPr id="6" name="頁尾版面配置區 5">
             <a:extLst>
               <a:ext uri="{FF2B5EF4-FFF2-40B4-BE49-F238E27FC236}">
-                <a16:creationId xmlns:a16="http://schemas.microsoft.com/office/drawing/2014/main" id="{09F06DB0-54D0-216F-514F-32389CD69013}"/>
+                <a16:creationId xmlns:a16="http://schemas.microsoft.com/office/drawing/2014/main" xmlns="" id="{09F06DB0-54D0-216F-514F-32389CD69013}"/>
               </a:ext>
             </a:extLst>
           </p:cNvPr>
@@ -5948,7 +5948,7 @@
           <p:cNvPr id="7" name="投影片編號版面配置區 6">
             <a:extLst>
               <a:ext uri="{FF2B5EF4-FFF2-40B4-BE49-F238E27FC236}">
-                <a16:creationId xmlns:a16="http://schemas.microsoft.com/office/drawing/2014/main" id="{383AE05C-A591-8A79-2654-4EE9364492D8}"/>
+                <a16:creationId xmlns:a16="http://schemas.microsoft.com/office/drawing/2014/main" xmlns="" id="{383AE05C-A591-8A79-2654-4EE9364492D8}"/>
               </a:ext>
             </a:extLst>
           </p:cNvPr>
@@ -6007,7 +6007,7 @@
           <p:cNvPr id="2" name="標題 1">
             <a:extLst>
               <a:ext uri="{FF2B5EF4-FFF2-40B4-BE49-F238E27FC236}">
-                <a16:creationId xmlns:a16="http://schemas.microsoft.com/office/drawing/2014/main" id="{B629405A-8BB9-550C-7931-2BE7C855C1F2}"/>
+                <a16:creationId xmlns:a16="http://schemas.microsoft.com/office/drawing/2014/main" xmlns="" id="{B629405A-8BB9-550C-7931-2BE7C855C1F2}"/>
               </a:ext>
             </a:extLst>
           </p:cNvPr>
@@ -6044,7 +6044,7 @@
           <p:cNvPr id="3" name="圖片版面配置區 2">
             <a:extLst>
               <a:ext uri="{FF2B5EF4-FFF2-40B4-BE49-F238E27FC236}">
-                <a16:creationId xmlns:a16="http://schemas.microsoft.com/office/drawing/2014/main" id="{52AE16E8-89E2-9385-7E4C-43A40A65C24E}"/>
+                <a16:creationId xmlns:a16="http://schemas.microsoft.com/office/drawing/2014/main" xmlns="" id="{52AE16E8-89E2-9385-7E4C-43A40A65C24E}"/>
               </a:ext>
             </a:extLst>
           </p:cNvPr>
@@ -6111,7 +6111,7 @@
           <p:cNvPr id="4" name="文字版面配置區 3">
             <a:extLst>
               <a:ext uri="{FF2B5EF4-FFF2-40B4-BE49-F238E27FC236}">
-                <a16:creationId xmlns:a16="http://schemas.microsoft.com/office/drawing/2014/main" id="{7AEE53F7-34DD-9EB2-C15A-065555AF246D}"/>
+                <a16:creationId xmlns:a16="http://schemas.microsoft.com/office/drawing/2014/main" xmlns="" id="{7AEE53F7-34DD-9EB2-C15A-065555AF246D}"/>
               </a:ext>
             </a:extLst>
           </p:cNvPr>
@@ -6182,7 +6182,7 @@
           <p:cNvPr id="5" name="日期版面配置區 4">
             <a:extLst>
               <a:ext uri="{FF2B5EF4-FFF2-40B4-BE49-F238E27FC236}">
-                <a16:creationId xmlns:a16="http://schemas.microsoft.com/office/drawing/2014/main" id="{6EB6D6D7-C4DE-8D28-B4A0-1250E1B1AA28}"/>
+                <a16:creationId xmlns:a16="http://schemas.microsoft.com/office/drawing/2014/main" xmlns="" id="{6EB6D6D7-C4DE-8D28-B4A0-1250E1B1AA28}"/>
               </a:ext>
             </a:extLst>
           </p:cNvPr>
@@ -6200,7 +6200,7 @@
           <a:p>
             <a:fld id="{746F9C1A-3528-47D7-9DBD-D23441465755}" type="datetimeFigureOut">
               <a:rPr lang="zh-TW" altLang="en-US" smtClean="0"/>
-              <a:t>2026/8/22</a:t>
+              <a:t>2026/8/24</a:t>
             </a:fld>
             <a:endParaRPr lang="zh-TW" altLang="en-US"/>
           </a:p>
@@ -6211,7 +6211,7 @@
           <p:cNvPr id="6" name="頁尾版面配置區 5">
             <a:extLst>
               <a:ext uri="{FF2B5EF4-FFF2-40B4-BE49-F238E27FC236}">
-                <a16:creationId xmlns:a16="http://schemas.microsoft.com/office/drawing/2014/main" id="{4BC68391-2D8D-4A2A-3C43-FDE65398AD82}"/>
+                <a16:creationId xmlns:a16="http://schemas.microsoft.com/office/drawing/2014/main" xmlns="" id="{4BC68391-2D8D-4A2A-3C43-FDE65398AD82}"/>
               </a:ext>
             </a:extLst>
           </p:cNvPr>
@@ -6236,7 +6236,7 @@
           <p:cNvPr id="7" name="投影片編號版面配置區 6">
             <a:extLst>
               <a:ext uri="{FF2B5EF4-FFF2-40B4-BE49-F238E27FC236}">
-                <a16:creationId xmlns:a16="http://schemas.microsoft.com/office/drawing/2014/main" id="{06BF11BB-AEE6-CDD8-FD08-E43F71B3A566}"/>
+                <a16:creationId xmlns:a16="http://schemas.microsoft.com/office/drawing/2014/main" xmlns="" id="{06BF11BB-AEE6-CDD8-FD08-E43F71B3A566}"/>
               </a:ext>
             </a:extLst>
           </p:cNvPr>
@@ -6300,7 +6300,7 @@
           <p:cNvPr id="2" name="標題版面配置區 1">
             <a:extLst>
               <a:ext uri="{FF2B5EF4-FFF2-40B4-BE49-F238E27FC236}">
-                <a16:creationId xmlns:a16="http://schemas.microsoft.com/office/drawing/2014/main" id="{EB49E9F7-2CCA-9638-149C-A6801F065349}"/>
+                <a16:creationId xmlns:a16="http://schemas.microsoft.com/office/drawing/2014/main" xmlns="" id="{EB49E9F7-2CCA-9638-149C-A6801F065349}"/>
               </a:ext>
             </a:extLst>
           </p:cNvPr>
@@ -6338,7 +6338,7 @@
           <p:cNvPr id="3" name="文字版面配置區 2">
             <a:extLst>
               <a:ext uri="{FF2B5EF4-FFF2-40B4-BE49-F238E27FC236}">
-                <a16:creationId xmlns:a16="http://schemas.microsoft.com/office/drawing/2014/main" id="{5CADBA5D-E6FC-831D-61A5-5BFF93152503}"/>
+                <a16:creationId xmlns:a16="http://schemas.microsoft.com/office/drawing/2014/main" xmlns="" id="{5CADBA5D-E6FC-831D-61A5-5BFF93152503}"/>
               </a:ext>
             </a:extLst>
           </p:cNvPr>
@@ -6405,7 +6405,7 @@
           <p:cNvPr id="4" name="日期版面配置區 3">
             <a:extLst>
               <a:ext uri="{FF2B5EF4-FFF2-40B4-BE49-F238E27FC236}">
-                <a16:creationId xmlns:a16="http://schemas.microsoft.com/office/drawing/2014/main" id="{7E1AC40C-1BC9-0BB1-964F-DC0C8747D3B2}"/>
+                <a16:creationId xmlns:a16="http://schemas.microsoft.com/office/drawing/2014/main" xmlns="" id="{7E1AC40C-1BC9-0BB1-964F-DC0C8747D3B2}"/>
               </a:ext>
             </a:extLst>
           </p:cNvPr>
@@ -6441,7 +6441,7 @@
           <a:p>
             <a:fld id="{746F9C1A-3528-47D7-9DBD-D23441465755}" type="datetimeFigureOut">
               <a:rPr lang="zh-TW" altLang="en-US" smtClean="0"/>
-              <a:t>2026/8/22</a:t>
+              <a:t>2026/8/24</a:t>
             </a:fld>
             <a:endParaRPr lang="zh-TW" altLang="en-US"/>
           </a:p>
@@ -6452,7 +6452,7 @@
           <p:cNvPr id="5" name="頁尾版面配置區 4">
             <a:extLst>
               <a:ext uri="{FF2B5EF4-FFF2-40B4-BE49-F238E27FC236}">
-                <a16:creationId xmlns:a16="http://schemas.microsoft.com/office/drawing/2014/main" id="{935E8620-E116-12E1-7450-49C11F2CF4FD}"/>
+                <a16:creationId xmlns:a16="http://schemas.microsoft.com/office/drawing/2014/main" xmlns="" id="{935E8620-E116-12E1-7450-49C11F2CF4FD}"/>
               </a:ext>
             </a:extLst>
           </p:cNvPr>
@@ -6495,7 +6495,7 @@
           <p:cNvPr id="6" name="投影片編號版面配置區 5">
             <a:extLst>
               <a:ext uri="{FF2B5EF4-FFF2-40B4-BE49-F238E27FC236}">
-                <a16:creationId xmlns:a16="http://schemas.microsoft.com/office/drawing/2014/main" id="{7C934E28-D756-645E-F683-ACF30D6EB263}"/>
+                <a16:creationId xmlns:a16="http://schemas.microsoft.com/office/drawing/2014/main" xmlns="" id="{7C934E28-D756-645E-F683-ACF30D6EB263}"/>
               </a:ext>
             </a:extLst>
           </p:cNvPr>
@@ -7037,7 +7037,7 @@
           <a:p>
             <a:fld id="{01F2E14E-90DA-4348-BFC3-233F8518E0D1}" type="datetimeFigureOut">
               <a:rPr lang="zh-TW" altLang="en-US" smtClean="0"/>
-              <a:t>2026/8/22</a:t>
+              <a:t>2026/8/24</a:t>
             </a:fld>
             <a:endParaRPr lang="zh-TW" altLang="en-US"/>
           </a:p>
@@ -7122,7 +7122,7 @@
           <p:cNvPr id="11" name="月亮 10">
             <a:extLst>
               <a:ext uri="{FF2B5EF4-FFF2-40B4-BE49-F238E27FC236}">
-                <a16:creationId xmlns:a16="http://schemas.microsoft.com/office/drawing/2014/main" id="{097930DD-E992-4608-A547-41CB73771488}"/>
+                <a16:creationId xmlns:a16="http://schemas.microsoft.com/office/drawing/2014/main" xmlns="" id="{097930DD-E992-4608-A547-41CB73771488}"/>
               </a:ext>
             </a:extLst>
           </p:cNvPr>
@@ -7176,7 +7176,7 @@
           <p:cNvPr id="13" name="月亮 12">
             <a:extLst>
               <a:ext uri="{FF2B5EF4-FFF2-40B4-BE49-F238E27FC236}">
-                <a16:creationId xmlns:a16="http://schemas.microsoft.com/office/drawing/2014/main" id="{42285FFD-56C1-4570-9837-41F03CBC48B2}"/>
+                <a16:creationId xmlns:a16="http://schemas.microsoft.com/office/drawing/2014/main" xmlns="" id="{42285FFD-56C1-4570-9837-41F03CBC48B2}"/>
               </a:ext>
             </a:extLst>
           </p:cNvPr>
@@ -7552,7 +7552,7 @@
           <p:cNvPr id="2" name="標題 1">
             <a:extLst>
               <a:ext uri="{FF2B5EF4-FFF2-40B4-BE49-F238E27FC236}">
-                <a16:creationId xmlns:a16="http://schemas.microsoft.com/office/drawing/2014/main" id="{0CCC7E27-5E1F-53FF-05BC-FE8B9C22A014}"/>
+                <a16:creationId xmlns:a16="http://schemas.microsoft.com/office/drawing/2014/main" xmlns="" id="{0CCC7E27-5E1F-53FF-05BC-FE8B9C22A014}"/>
               </a:ext>
             </a:extLst>
           </p:cNvPr>
@@ -7577,7 +7577,7 @@
           <p:cNvPr id="4" name="文字方塊 3">
             <a:extLst>
               <a:ext uri="{FF2B5EF4-FFF2-40B4-BE49-F238E27FC236}">
-                <a16:creationId xmlns:a16="http://schemas.microsoft.com/office/drawing/2014/main" id="{A12A284D-8000-860D-A366-D77D742F71DA}"/>
+                <a16:creationId xmlns:a16="http://schemas.microsoft.com/office/drawing/2014/main" xmlns="" id="{A12A284D-8000-860D-A366-D77D742F71DA}"/>
               </a:ext>
             </a:extLst>
           </p:cNvPr>
@@ -7620,7 +7620,7 @@
           <p:cNvPr id="5" name="圖片 4">
             <a:extLst>
               <a:ext uri="{FF2B5EF4-FFF2-40B4-BE49-F238E27FC236}">
-                <a16:creationId xmlns:a16="http://schemas.microsoft.com/office/drawing/2014/main" id="{D574415B-018C-8686-257C-74A44D21354B}"/>
+                <a16:creationId xmlns:a16="http://schemas.microsoft.com/office/drawing/2014/main" xmlns="" id="{D574415B-018C-8686-257C-74A44D21354B}"/>
               </a:ext>
             </a:extLst>
           </p:cNvPr>
@@ -7650,7 +7650,7 @@
           <p:cNvPr id="6" name="圖片 5">
             <a:extLst>
               <a:ext uri="{FF2B5EF4-FFF2-40B4-BE49-F238E27FC236}">
-                <a16:creationId xmlns:a16="http://schemas.microsoft.com/office/drawing/2014/main" id="{3D355E62-0B8C-4272-F1B2-C87608BCEB6E}"/>
+                <a16:creationId xmlns:a16="http://schemas.microsoft.com/office/drawing/2014/main" xmlns="" id="{3D355E62-0B8C-4272-F1B2-C87608BCEB6E}"/>
               </a:ext>
             </a:extLst>
           </p:cNvPr>
@@ -7680,7 +7680,7 @@
           <p:cNvPr id="7" name="圖片 6">
             <a:extLst>
               <a:ext uri="{FF2B5EF4-FFF2-40B4-BE49-F238E27FC236}">
-                <a16:creationId xmlns:a16="http://schemas.microsoft.com/office/drawing/2014/main" id="{49983771-F03F-8F51-43F8-C6208C2318AB}"/>
+                <a16:creationId xmlns:a16="http://schemas.microsoft.com/office/drawing/2014/main" xmlns="" id="{49983771-F03F-8F51-43F8-C6208C2318AB}"/>
               </a:ext>
             </a:extLst>
           </p:cNvPr>
@@ -7710,7 +7710,7 @@
           <p:cNvPr id="8" name="文字方塊 7">
             <a:extLst>
               <a:ext uri="{FF2B5EF4-FFF2-40B4-BE49-F238E27FC236}">
-                <a16:creationId xmlns:a16="http://schemas.microsoft.com/office/drawing/2014/main" id="{00BE8928-9E14-4369-77E1-CDB6F745FEF7}"/>
+                <a16:creationId xmlns:a16="http://schemas.microsoft.com/office/drawing/2014/main" xmlns="" id="{00BE8928-9E14-4369-77E1-CDB6F745FEF7}"/>
               </a:ext>
             </a:extLst>
           </p:cNvPr>
@@ -7795,7 +7795,7 @@
           <p:cNvPr id="3" name="圖片 2">
             <a:extLst>
               <a:ext uri="{FF2B5EF4-FFF2-40B4-BE49-F238E27FC236}">
-                <a16:creationId xmlns:a16="http://schemas.microsoft.com/office/drawing/2014/main" id="{BFA13BFC-45C7-5F06-EDB6-A259E022FC68}"/>
+                <a16:creationId xmlns:a16="http://schemas.microsoft.com/office/drawing/2014/main" xmlns="" id="{BFA13BFC-45C7-5F06-EDB6-A259E022FC68}"/>
               </a:ext>
             </a:extLst>
           </p:cNvPr>
@@ -7825,7 +7825,7 @@
           <p:cNvPr id="5" name="圖片 4">
             <a:extLst>
               <a:ext uri="{FF2B5EF4-FFF2-40B4-BE49-F238E27FC236}">
-                <a16:creationId xmlns:a16="http://schemas.microsoft.com/office/drawing/2014/main" id="{7D4278C0-D5C7-29DB-64E8-3EF278D04FC6}"/>
+                <a16:creationId xmlns:a16="http://schemas.microsoft.com/office/drawing/2014/main" xmlns="" id="{7D4278C0-D5C7-29DB-64E8-3EF278D04FC6}"/>
               </a:ext>
             </a:extLst>
           </p:cNvPr>
@@ -7855,7 +7855,7 @@
           <p:cNvPr id="7" name="圖片 6">
             <a:extLst>
               <a:ext uri="{FF2B5EF4-FFF2-40B4-BE49-F238E27FC236}">
-                <a16:creationId xmlns:a16="http://schemas.microsoft.com/office/drawing/2014/main" id="{74533355-35C1-47DB-8DD9-D3BF2FF65ABC}"/>
+                <a16:creationId xmlns:a16="http://schemas.microsoft.com/office/drawing/2014/main" xmlns="" id="{74533355-35C1-47DB-8DD9-D3BF2FF65ABC}"/>
               </a:ext>
             </a:extLst>
           </p:cNvPr>
@@ -7885,7 +7885,7 @@
           <p:cNvPr id="8" name="文字方塊 7">
             <a:extLst>
               <a:ext uri="{FF2B5EF4-FFF2-40B4-BE49-F238E27FC236}">
-                <a16:creationId xmlns:a16="http://schemas.microsoft.com/office/drawing/2014/main" id="{3C5F46FC-D72D-28B6-AB7C-767B6ECEBBBD}"/>
+                <a16:creationId xmlns:a16="http://schemas.microsoft.com/office/drawing/2014/main" xmlns="" id="{3C5F46FC-D72D-28B6-AB7C-767B6ECEBBBD}"/>
               </a:ext>
             </a:extLst>
           </p:cNvPr>
@@ -7920,7 +7920,7 @@
           <p:cNvPr id="10" name="圖片 9">
             <a:extLst>
               <a:ext uri="{FF2B5EF4-FFF2-40B4-BE49-F238E27FC236}">
-                <a16:creationId xmlns:a16="http://schemas.microsoft.com/office/drawing/2014/main" id="{60A301A0-01E8-414A-D751-786C46C767FA}"/>
+                <a16:creationId xmlns:a16="http://schemas.microsoft.com/office/drawing/2014/main" xmlns="" id="{60A301A0-01E8-414A-D751-786C46C767FA}"/>
               </a:ext>
             </a:extLst>
           </p:cNvPr>
@@ -7950,7 +7950,7 @@
           <p:cNvPr id="11" name="文字方塊 10">
             <a:extLst>
               <a:ext uri="{FF2B5EF4-FFF2-40B4-BE49-F238E27FC236}">
-                <a16:creationId xmlns:a16="http://schemas.microsoft.com/office/drawing/2014/main" id="{BD42C23F-35C2-61D9-9BB4-7E85F2349212}"/>
+                <a16:creationId xmlns:a16="http://schemas.microsoft.com/office/drawing/2014/main" xmlns="" id="{BD42C23F-35C2-61D9-9BB4-7E85F2349212}"/>
               </a:ext>
             </a:extLst>
           </p:cNvPr>
@@ -7993,7 +7993,7 @@
           <p:cNvPr id="13" name="圖片 12">
             <a:extLst>
               <a:ext uri="{FF2B5EF4-FFF2-40B4-BE49-F238E27FC236}">
-                <a16:creationId xmlns:a16="http://schemas.microsoft.com/office/drawing/2014/main" id="{69F560E6-B6E5-AA60-D335-D9496FD88275}"/>
+                <a16:creationId xmlns:a16="http://schemas.microsoft.com/office/drawing/2014/main" xmlns="" id="{69F560E6-B6E5-AA60-D335-D9496FD88275}"/>
               </a:ext>
             </a:extLst>
           </p:cNvPr>
@@ -8023,7 +8023,7 @@
           <p:cNvPr id="2" name="標題 1">
             <a:extLst>
               <a:ext uri="{FF2B5EF4-FFF2-40B4-BE49-F238E27FC236}">
-                <a16:creationId xmlns:a16="http://schemas.microsoft.com/office/drawing/2014/main" id="{53F97213-C462-81C8-AFC6-45554E3DE8AF}"/>
+                <a16:creationId xmlns:a16="http://schemas.microsoft.com/office/drawing/2014/main" xmlns="" id="{53F97213-C462-81C8-AFC6-45554E3DE8AF}"/>
               </a:ext>
             </a:extLst>
           </p:cNvPr>
@@ -8092,7 +8092,7 @@
         <p:cNvPr id="1" name="">
           <a:extLst>
             <a:ext uri="{FF2B5EF4-FFF2-40B4-BE49-F238E27FC236}">
-              <a16:creationId xmlns:a16="http://schemas.microsoft.com/office/drawing/2014/main" id="{0996B5CF-F0BF-FCFB-E8CC-8B649694C3B3}"/>
+              <a16:creationId xmlns:a16="http://schemas.microsoft.com/office/drawing/2014/main" xmlns="" id="{0996B5CF-F0BF-FCFB-E8CC-8B649694C3B3}"/>
             </a:ext>
           </a:extLst>
         </p:cNvPr>
@@ -8112,7 +8112,7 @@
           <p:cNvPr id="2" name="標題 1">
             <a:extLst>
               <a:ext uri="{FF2B5EF4-FFF2-40B4-BE49-F238E27FC236}">
-                <a16:creationId xmlns:a16="http://schemas.microsoft.com/office/drawing/2014/main" id="{C5A1BAB6-6502-3D77-150C-02D42B4080CA}"/>
+                <a16:creationId xmlns:a16="http://schemas.microsoft.com/office/drawing/2014/main" xmlns="" id="{C5A1BAB6-6502-3D77-150C-02D42B4080CA}"/>
               </a:ext>
             </a:extLst>
           </p:cNvPr>
@@ -8151,7 +8151,7 @@
           <p:cNvPr id="3" name="文字方塊 2">
             <a:extLst>
               <a:ext uri="{FF2B5EF4-FFF2-40B4-BE49-F238E27FC236}">
-                <a16:creationId xmlns:a16="http://schemas.microsoft.com/office/drawing/2014/main" id="{5A70E20E-DFE4-2F90-1C36-A501BBA49666}"/>
+                <a16:creationId xmlns:a16="http://schemas.microsoft.com/office/drawing/2014/main" xmlns="" id="{5A70E20E-DFE4-2F90-1C36-A501BBA49666}"/>
               </a:ext>
             </a:extLst>
           </p:cNvPr>
@@ -8289,7 +8289,7 @@
           <p:cNvPr id="5" name="圖片 4">
             <a:extLst>
               <a:ext uri="{FF2B5EF4-FFF2-40B4-BE49-F238E27FC236}">
-                <a16:creationId xmlns:a16="http://schemas.microsoft.com/office/drawing/2014/main" id="{14F1C779-FB08-7775-DB79-B237DD385F6E}"/>
+                <a16:creationId xmlns:a16="http://schemas.microsoft.com/office/drawing/2014/main" xmlns="" id="{14F1C779-FB08-7775-DB79-B237DD385F6E}"/>
               </a:ext>
             </a:extLst>
           </p:cNvPr>
@@ -8433,7 +8433,7 @@
           <p:cNvPr id="4" name="內容版面配置區 2">
             <a:extLst>
               <a:ext uri="{FF2B5EF4-FFF2-40B4-BE49-F238E27FC236}">
-                <a16:creationId xmlns:a16="http://schemas.microsoft.com/office/drawing/2014/main" id="{1D0E8889-394E-45EB-AD63-27FE775FB222}"/>
+                <a16:creationId xmlns:a16="http://schemas.microsoft.com/office/drawing/2014/main" xmlns="" id="{1D0E8889-394E-45EB-AD63-27FE775FB222}"/>
               </a:ext>
             </a:extLst>
           </p:cNvPr>
@@ -8658,7 +8658,7 @@
           <p:cNvPr id="15" name="內容版面配置區 2">
             <a:extLst>
               <a:ext uri="{FF2B5EF4-FFF2-40B4-BE49-F238E27FC236}">
-                <a16:creationId xmlns:a16="http://schemas.microsoft.com/office/drawing/2014/main" id="{306776B7-C0DB-4BF7-B0B3-033B41E39ED1}"/>
+                <a16:creationId xmlns:a16="http://schemas.microsoft.com/office/drawing/2014/main" xmlns="" id="{306776B7-C0DB-4BF7-B0B3-033B41E39ED1}"/>
               </a:ext>
             </a:extLst>
           </p:cNvPr>
@@ -8979,7 +8979,7 @@
           <p:cNvPr id="8" name="圖片 7">
             <a:extLst>
               <a:ext uri="{FF2B5EF4-FFF2-40B4-BE49-F238E27FC236}">
-                <a16:creationId xmlns:a16="http://schemas.microsoft.com/office/drawing/2014/main" id="{5D6096CC-8AD2-451A-9112-308CC4ADDAB6}"/>
+                <a16:creationId xmlns:a16="http://schemas.microsoft.com/office/drawing/2014/main" xmlns="" id="{5D6096CC-8AD2-451A-9112-308CC4ADDAB6}"/>
               </a:ext>
             </a:extLst>
           </p:cNvPr>
@@ -9020,7 +9020,7 @@
           <p:cNvPr id="9" name="圖片 8">
             <a:extLst>
               <a:ext uri="{FF2B5EF4-FFF2-40B4-BE49-F238E27FC236}">
-                <a16:creationId xmlns:a16="http://schemas.microsoft.com/office/drawing/2014/main" id="{E062EF3C-6E39-436C-BB53-67CC8A3B4B45}"/>
+                <a16:creationId xmlns:a16="http://schemas.microsoft.com/office/drawing/2014/main" xmlns="" id="{E062EF3C-6E39-436C-BB53-67CC8A3B4B45}"/>
               </a:ext>
             </a:extLst>
           </p:cNvPr>
@@ -9061,7 +9061,7 @@
           <p:cNvPr id="11" name="圖片 10">
             <a:extLst>
               <a:ext uri="{FF2B5EF4-FFF2-40B4-BE49-F238E27FC236}">
-                <a16:creationId xmlns:a16="http://schemas.microsoft.com/office/drawing/2014/main" id="{E62B6EB7-D104-43EE-AA61-DDD02AC35E57}"/>
+                <a16:creationId xmlns:a16="http://schemas.microsoft.com/office/drawing/2014/main" xmlns="" id="{E62B6EB7-D104-43EE-AA61-DDD02AC35E57}"/>
               </a:ext>
             </a:extLst>
           </p:cNvPr>
@@ -9132,7 +9132,7 @@
           <p:cNvPr id="3" name="圖片 2">
             <a:extLst>
               <a:ext uri="{FF2B5EF4-FFF2-40B4-BE49-F238E27FC236}">
-                <a16:creationId xmlns:a16="http://schemas.microsoft.com/office/drawing/2014/main" id="{3EC41D10-0FC2-D712-3B51-991DC505F6DD}"/>
+                <a16:creationId xmlns:a16="http://schemas.microsoft.com/office/drawing/2014/main" xmlns="" id="{3EC41D10-0FC2-D712-3B51-991DC505F6DD}"/>
               </a:ext>
             </a:extLst>
           </p:cNvPr>
@@ -9162,7 +9162,7 @@
           <p:cNvPr id="4" name="矩形 3">
             <a:extLst>
               <a:ext uri="{FF2B5EF4-FFF2-40B4-BE49-F238E27FC236}">
-                <a16:creationId xmlns:a16="http://schemas.microsoft.com/office/drawing/2014/main" id="{DD5CAE50-0790-2E52-A5CD-2DA9F3FAD388}"/>
+                <a16:creationId xmlns:a16="http://schemas.microsoft.com/office/drawing/2014/main" xmlns="" id="{DD5CAE50-0790-2E52-A5CD-2DA9F3FAD388}"/>
               </a:ext>
             </a:extLst>
           </p:cNvPr>
@@ -9212,7 +9212,7 @@
           <p:cNvPr id="5" name="矩形 4">
             <a:extLst>
               <a:ext uri="{FF2B5EF4-FFF2-40B4-BE49-F238E27FC236}">
-                <a16:creationId xmlns:a16="http://schemas.microsoft.com/office/drawing/2014/main" id="{93C7F4CC-A95A-6D17-11DC-AD71221211D9}"/>
+                <a16:creationId xmlns:a16="http://schemas.microsoft.com/office/drawing/2014/main" xmlns="" id="{93C7F4CC-A95A-6D17-11DC-AD71221211D9}"/>
               </a:ext>
             </a:extLst>
           </p:cNvPr>
@@ -9262,7 +9262,7 @@
           <p:cNvPr id="6" name="文字方塊 5">
             <a:extLst>
               <a:ext uri="{FF2B5EF4-FFF2-40B4-BE49-F238E27FC236}">
-                <a16:creationId xmlns:a16="http://schemas.microsoft.com/office/drawing/2014/main" id="{9312A522-73E4-CB07-74D6-1965C7ABD978}"/>
+                <a16:creationId xmlns:a16="http://schemas.microsoft.com/office/drawing/2014/main" xmlns="" id="{9312A522-73E4-CB07-74D6-1965C7ABD978}"/>
               </a:ext>
             </a:extLst>
           </p:cNvPr>
@@ -9341,7 +9341,7 @@
           <p:cNvPr id="8" name="圖片 7">
             <a:extLst>
               <a:ext uri="{FF2B5EF4-FFF2-40B4-BE49-F238E27FC236}">
-                <a16:creationId xmlns:a16="http://schemas.microsoft.com/office/drawing/2014/main" id="{425E5C2C-8E69-F73E-A277-9F98C4C67B51}"/>
+                <a16:creationId xmlns:a16="http://schemas.microsoft.com/office/drawing/2014/main" xmlns="" id="{425E5C2C-8E69-F73E-A277-9F98C4C67B51}"/>
               </a:ext>
             </a:extLst>
           </p:cNvPr>
@@ -9371,7 +9371,7 @@
           <p:cNvPr id="9" name="文字方塊 8">
             <a:extLst>
               <a:ext uri="{FF2B5EF4-FFF2-40B4-BE49-F238E27FC236}">
-                <a16:creationId xmlns:a16="http://schemas.microsoft.com/office/drawing/2014/main" id="{FFD09778-A626-4D49-61E6-28FF5384369E}"/>
+                <a16:creationId xmlns:a16="http://schemas.microsoft.com/office/drawing/2014/main" xmlns="" id="{FFD09778-A626-4D49-61E6-28FF5384369E}"/>
               </a:ext>
             </a:extLst>
           </p:cNvPr>
@@ -9413,7 +9413,7 @@
           <p:cNvPr id="12" name="矩形 11">
             <a:extLst>
               <a:ext uri="{FF2B5EF4-FFF2-40B4-BE49-F238E27FC236}">
-                <a16:creationId xmlns:a16="http://schemas.microsoft.com/office/drawing/2014/main" id="{4D93FEA2-F306-63C9-02C9-5EFF146CE36F}"/>
+                <a16:creationId xmlns:a16="http://schemas.microsoft.com/office/drawing/2014/main" xmlns="" id="{4D93FEA2-F306-63C9-02C9-5EFF146CE36F}"/>
               </a:ext>
             </a:extLst>
           </p:cNvPr>
@@ -9463,7 +9463,7 @@
           <p:cNvPr id="13" name="箭號: ＞形 12">
             <a:extLst>
               <a:ext uri="{FF2B5EF4-FFF2-40B4-BE49-F238E27FC236}">
-                <a16:creationId xmlns:a16="http://schemas.microsoft.com/office/drawing/2014/main" id="{EBC2E299-B605-7FB3-B270-0FA68FFF7BC1}"/>
+                <a16:creationId xmlns:a16="http://schemas.microsoft.com/office/drawing/2014/main" xmlns="" id="{EBC2E299-B605-7FB3-B270-0FA68FFF7BC1}"/>
               </a:ext>
             </a:extLst>
           </p:cNvPr>
@@ -9513,7 +9513,7 @@
           <p:cNvPr id="7" name="直線單箭頭接點 6">
             <a:extLst>
               <a:ext uri="{FF2B5EF4-FFF2-40B4-BE49-F238E27FC236}">
-                <a16:creationId xmlns:a16="http://schemas.microsoft.com/office/drawing/2014/main" id="{E993F1C1-A1F0-8675-6D9B-A5B94891DB4E}"/>
+                <a16:creationId xmlns:a16="http://schemas.microsoft.com/office/drawing/2014/main" xmlns="" id="{E993F1C1-A1F0-8675-6D9B-A5B94891DB4E}"/>
               </a:ext>
             </a:extLst>
           </p:cNvPr>
@@ -9582,7 +9582,7 @@
           <p:cNvPr id="3" name="圖片 2">
             <a:extLst>
               <a:ext uri="{FF2B5EF4-FFF2-40B4-BE49-F238E27FC236}">
-                <a16:creationId xmlns:a16="http://schemas.microsoft.com/office/drawing/2014/main" id="{694852A2-64BD-BDBD-B33A-FE79A97020B6}"/>
+                <a16:creationId xmlns:a16="http://schemas.microsoft.com/office/drawing/2014/main" xmlns="" id="{694852A2-64BD-BDBD-B33A-FE79A97020B6}"/>
               </a:ext>
             </a:extLst>
           </p:cNvPr>
@@ -9744,7 +9744,7 @@
           <p:cNvPr id="6" name="圖片 5">
             <a:extLst>
               <a:ext uri="{FF2B5EF4-FFF2-40B4-BE49-F238E27FC236}">
-                <a16:creationId xmlns:a16="http://schemas.microsoft.com/office/drawing/2014/main" id="{6D444014-7FBE-4ACE-9C8B-AC5D9C8026E5}"/>
+                <a16:creationId xmlns:a16="http://schemas.microsoft.com/office/drawing/2014/main" xmlns="" id="{6D444014-7FBE-4ACE-9C8B-AC5D9C8026E5}"/>
               </a:ext>
             </a:extLst>
           </p:cNvPr>
@@ -9853,7 +9853,7 @@
           <p:cNvPr id="6" name="內容版面配置區 2">
             <a:extLst>
               <a:ext uri="{FF2B5EF4-FFF2-40B4-BE49-F238E27FC236}">
-                <a16:creationId xmlns:a16="http://schemas.microsoft.com/office/drawing/2014/main" id="{4CC1465C-01EA-42E7-8DC4-B1A47787CBEC}"/>
+                <a16:creationId xmlns:a16="http://schemas.microsoft.com/office/drawing/2014/main" xmlns="" id="{4CC1465C-01EA-42E7-8DC4-B1A47787CBEC}"/>
               </a:ext>
             </a:extLst>
           </p:cNvPr>
@@ -10198,7 +10198,7 @@
           <p:cNvPr id="5" name="圖片 4">
             <a:extLst>
               <a:ext uri="{FF2B5EF4-FFF2-40B4-BE49-F238E27FC236}">
-                <a16:creationId xmlns:a16="http://schemas.microsoft.com/office/drawing/2014/main" id="{D4CABAFE-3EBD-443C-8C06-9E0ED67A037C}"/>
+                <a16:creationId xmlns:a16="http://schemas.microsoft.com/office/drawing/2014/main" xmlns="" id="{D4CABAFE-3EBD-443C-8C06-9E0ED67A037C}"/>
               </a:ext>
             </a:extLst>
           </p:cNvPr>
@@ -10228,7 +10228,7 @@
           <p:cNvPr id="7" name="圖片 6">
             <a:extLst>
               <a:ext uri="{FF2B5EF4-FFF2-40B4-BE49-F238E27FC236}">
-                <a16:creationId xmlns:a16="http://schemas.microsoft.com/office/drawing/2014/main" id="{BA0569A7-6848-464D-8E63-76010AD35A80}"/>
+                <a16:creationId xmlns:a16="http://schemas.microsoft.com/office/drawing/2014/main" xmlns="" id="{BA0569A7-6848-464D-8E63-76010AD35A80}"/>
               </a:ext>
             </a:extLst>
           </p:cNvPr>
@@ -10263,7 +10263,7 @@
           <p:cNvPr id="8" name="圖片 7">
             <a:extLst>
               <a:ext uri="{FF2B5EF4-FFF2-40B4-BE49-F238E27FC236}">
-                <a16:creationId xmlns:a16="http://schemas.microsoft.com/office/drawing/2014/main" id="{DB149A7C-5A75-4D03-9808-844B64B2FA23}"/>
+                <a16:creationId xmlns:a16="http://schemas.microsoft.com/office/drawing/2014/main" xmlns="" id="{DB149A7C-5A75-4D03-9808-844B64B2FA23}"/>
               </a:ext>
             </a:extLst>
           </p:cNvPr>
@@ -10372,7 +10372,7 @@
           <p:cNvPr id="4" name="內容版面配置區 2">
             <a:extLst>
               <a:ext uri="{FF2B5EF4-FFF2-40B4-BE49-F238E27FC236}">
-                <a16:creationId xmlns:a16="http://schemas.microsoft.com/office/drawing/2014/main" id="{1D0E8889-394E-45EB-AD63-27FE775FB222}"/>
+                <a16:creationId xmlns:a16="http://schemas.microsoft.com/office/drawing/2014/main" xmlns="" id="{1D0E8889-394E-45EB-AD63-27FE775FB222}"/>
               </a:ext>
             </a:extLst>
           </p:cNvPr>
@@ -10618,7 +10618,7 @@
           <p:cNvPr id="6" name="圖片 5">
             <a:extLst>
               <a:ext uri="{FF2B5EF4-FFF2-40B4-BE49-F238E27FC236}">
-                <a16:creationId xmlns:a16="http://schemas.microsoft.com/office/drawing/2014/main" id="{B8C7465A-DAD7-49A3-9BE8-3FD5DD779C0E}"/>
+                <a16:creationId xmlns:a16="http://schemas.microsoft.com/office/drawing/2014/main" xmlns="" id="{B8C7465A-DAD7-49A3-9BE8-3FD5DD779C0E}"/>
               </a:ext>
             </a:extLst>
           </p:cNvPr>
@@ -10678,7 +10678,7 @@
           <p:cNvPr id="2" name="標題 1">
             <a:extLst>
               <a:ext uri="{FF2B5EF4-FFF2-40B4-BE49-F238E27FC236}">
-                <a16:creationId xmlns:a16="http://schemas.microsoft.com/office/drawing/2014/main" id="{DC48CB13-1427-2AA7-AED6-526A06A5C7C7}"/>
+                <a16:creationId xmlns:a16="http://schemas.microsoft.com/office/drawing/2014/main" xmlns="" id="{DC48CB13-1427-2AA7-AED6-526A06A5C7C7}"/>
               </a:ext>
             </a:extLst>
           </p:cNvPr>
@@ -10716,7 +10716,7 @@
           <p:cNvPr id="4" name="圖片 3">
             <a:extLst>
               <a:ext uri="{FF2B5EF4-FFF2-40B4-BE49-F238E27FC236}">
-                <a16:creationId xmlns:a16="http://schemas.microsoft.com/office/drawing/2014/main" id="{AB0044A2-4B41-C5E0-4F32-7EF74C82569A}"/>
+                <a16:creationId xmlns:a16="http://schemas.microsoft.com/office/drawing/2014/main" xmlns="" id="{AB0044A2-4B41-C5E0-4F32-7EF74C82569A}"/>
               </a:ext>
             </a:extLst>
           </p:cNvPr>
@@ -10746,7 +10746,7 @@
           <p:cNvPr id="6" name="圖片 5">
             <a:extLst>
               <a:ext uri="{FF2B5EF4-FFF2-40B4-BE49-F238E27FC236}">
-                <a16:creationId xmlns:a16="http://schemas.microsoft.com/office/drawing/2014/main" id="{0A23C218-4D5E-71DC-828A-D1394C0A1E23}"/>
+                <a16:creationId xmlns:a16="http://schemas.microsoft.com/office/drawing/2014/main" xmlns="" id="{0A23C218-4D5E-71DC-828A-D1394C0A1E23}"/>
               </a:ext>
             </a:extLst>
           </p:cNvPr>
@@ -10776,7 +10776,7 @@
           <p:cNvPr id="7" name="文字方塊 6">
             <a:extLst>
               <a:ext uri="{FF2B5EF4-FFF2-40B4-BE49-F238E27FC236}">
-                <a16:creationId xmlns:a16="http://schemas.microsoft.com/office/drawing/2014/main" id="{72961155-9A6D-AEB8-6FC9-BFE955914EE3}"/>
+                <a16:creationId xmlns:a16="http://schemas.microsoft.com/office/drawing/2014/main" xmlns="" id="{72961155-9A6D-AEB8-6FC9-BFE955914EE3}"/>
               </a:ext>
             </a:extLst>
           </p:cNvPr>
@@ -10821,7 +10821,7 @@
           <p:cNvPr id="9" name="圖片 8">
             <a:extLst>
               <a:ext uri="{FF2B5EF4-FFF2-40B4-BE49-F238E27FC236}">
-                <a16:creationId xmlns:a16="http://schemas.microsoft.com/office/drawing/2014/main" id="{815ABC9E-6297-6CA9-1F66-E320144C8FA1}"/>
+                <a16:creationId xmlns:a16="http://schemas.microsoft.com/office/drawing/2014/main" xmlns="" id="{815ABC9E-6297-6CA9-1F66-E320144C8FA1}"/>
               </a:ext>
             </a:extLst>
           </p:cNvPr>
@@ -10851,7 +10851,7 @@
           <p:cNvPr id="12" name="圖片 11">
             <a:extLst>
               <a:ext uri="{FF2B5EF4-FFF2-40B4-BE49-F238E27FC236}">
-                <a16:creationId xmlns:a16="http://schemas.microsoft.com/office/drawing/2014/main" id="{83210490-AF53-A90A-810B-8FAB03F7ACF5}"/>
+                <a16:creationId xmlns:a16="http://schemas.microsoft.com/office/drawing/2014/main" xmlns="" id="{83210490-AF53-A90A-810B-8FAB03F7ACF5}"/>
               </a:ext>
             </a:extLst>
           </p:cNvPr>
@@ -10881,7 +10881,7 @@
           <p:cNvPr id="13" name="文字方塊 12">
             <a:extLst>
               <a:ext uri="{FF2B5EF4-FFF2-40B4-BE49-F238E27FC236}">
-                <a16:creationId xmlns:a16="http://schemas.microsoft.com/office/drawing/2014/main" id="{86223BCC-538C-E8BC-F7A2-8213BF46052A}"/>
+                <a16:creationId xmlns:a16="http://schemas.microsoft.com/office/drawing/2014/main" xmlns="" id="{86223BCC-538C-E8BC-F7A2-8213BF46052A}"/>
               </a:ext>
             </a:extLst>
           </p:cNvPr>
@@ -10980,7 +10980,7 @@
           <p:cNvPr id="15" name="圖片 14">
             <a:extLst>
               <a:ext uri="{FF2B5EF4-FFF2-40B4-BE49-F238E27FC236}">
-                <a16:creationId xmlns:a16="http://schemas.microsoft.com/office/drawing/2014/main" id="{4D96943A-A055-74B3-BF08-3F9CE4291B0B}"/>
+                <a16:creationId xmlns:a16="http://schemas.microsoft.com/office/drawing/2014/main" xmlns="" id="{4D96943A-A055-74B3-BF08-3F9CE4291B0B}"/>
               </a:ext>
             </a:extLst>
           </p:cNvPr>
@@ -11010,7 +11010,7 @@
           <p:cNvPr id="16" name="矩形 15">
             <a:extLst>
               <a:ext uri="{FF2B5EF4-FFF2-40B4-BE49-F238E27FC236}">
-                <a16:creationId xmlns:a16="http://schemas.microsoft.com/office/drawing/2014/main" id="{4549D50A-894C-7F1D-3E6C-046789A234A7}"/>
+                <a16:creationId xmlns:a16="http://schemas.microsoft.com/office/drawing/2014/main" xmlns="" id="{4549D50A-894C-7F1D-3E6C-046789A234A7}"/>
               </a:ext>
             </a:extLst>
           </p:cNvPr>
@@ -11060,7 +11060,7 @@
           <p:cNvPr id="17" name="矩形 16">
             <a:extLst>
               <a:ext uri="{FF2B5EF4-FFF2-40B4-BE49-F238E27FC236}">
-                <a16:creationId xmlns:a16="http://schemas.microsoft.com/office/drawing/2014/main" id="{A540DD55-A99C-D65E-BADE-83F4AA313445}"/>
+                <a16:creationId xmlns:a16="http://schemas.microsoft.com/office/drawing/2014/main" xmlns="" id="{A540DD55-A99C-D65E-BADE-83F4AA313445}"/>
               </a:ext>
             </a:extLst>
           </p:cNvPr>
@@ -11110,7 +11110,7 @@
           <p:cNvPr id="18" name="矩形 17">
             <a:extLst>
               <a:ext uri="{FF2B5EF4-FFF2-40B4-BE49-F238E27FC236}">
-                <a16:creationId xmlns:a16="http://schemas.microsoft.com/office/drawing/2014/main" id="{48F12F87-2CFC-A3CA-D82F-E19C1E072FCC}"/>
+                <a16:creationId xmlns:a16="http://schemas.microsoft.com/office/drawing/2014/main" xmlns="" id="{48F12F87-2CFC-A3CA-D82F-E19C1E072FCC}"/>
               </a:ext>
             </a:extLst>
           </p:cNvPr>
@@ -11160,7 +11160,7 @@
           <p:cNvPr id="19" name="矩形 18">
             <a:extLst>
               <a:ext uri="{FF2B5EF4-FFF2-40B4-BE49-F238E27FC236}">
-                <a16:creationId xmlns:a16="http://schemas.microsoft.com/office/drawing/2014/main" id="{2BE9B56F-7F48-2436-56A6-A5608DBA8666}"/>
+                <a16:creationId xmlns:a16="http://schemas.microsoft.com/office/drawing/2014/main" xmlns="" id="{2BE9B56F-7F48-2436-56A6-A5608DBA8666}"/>
               </a:ext>
             </a:extLst>
           </p:cNvPr>
@@ -11240,7 +11240,7 @@
           <p:cNvPr id="3" name="圖片 2">
             <a:extLst>
               <a:ext uri="{FF2B5EF4-FFF2-40B4-BE49-F238E27FC236}">
-                <a16:creationId xmlns:a16="http://schemas.microsoft.com/office/drawing/2014/main" id="{E77EE36B-810C-8234-E5DF-E8CC0F301628}"/>
+                <a16:creationId xmlns:a16="http://schemas.microsoft.com/office/drawing/2014/main" xmlns="" id="{E77EE36B-810C-8234-E5DF-E8CC0F301628}"/>
               </a:ext>
             </a:extLst>
           </p:cNvPr>
@@ -11270,7 +11270,7 @@
           <p:cNvPr id="4" name="矩形 3">
             <a:extLst>
               <a:ext uri="{FF2B5EF4-FFF2-40B4-BE49-F238E27FC236}">
-                <a16:creationId xmlns:a16="http://schemas.microsoft.com/office/drawing/2014/main" id="{5D6CC5D0-597B-9D26-C605-91FEC5CBE287}"/>
+                <a16:creationId xmlns:a16="http://schemas.microsoft.com/office/drawing/2014/main" xmlns="" id="{5D6CC5D0-597B-9D26-C605-91FEC5CBE287}"/>
               </a:ext>
             </a:extLst>
           </p:cNvPr>
@@ -11320,7 +11320,7 @@
           <p:cNvPr id="5" name="文字方塊 4">
             <a:extLst>
               <a:ext uri="{FF2B5EF4-FFF2-40B4-BE49-F238E27FC236}">
-                <a16:creationId xmlns:a16="http://schemas.microsoft.com/office/drawing/2014/main" id="{0B27D642-8C99-047E-1C58-7FFAEEA77E08}"/>
+                <a16:creationId xmlns:a16="http://schemas.microsoft.com/office/drawing/2014/main" xmlns="" id="{0B27D642-8C99-047E-1C58-7FFAEEA77E08}"/>
               </a:ext>
             </a:extLst>
           </p:cNvPr>
@@ -11379,7 +11379,7 @@
           <p:cNvPr id="7" name="圖片 6">
             <a:extLst>
               <a:ext uri="{FF2B5EF4-FFF2-40B4-BE49-F238E27FC236}">
-                <a16:creationId xmlns:a16="http://schemas.microsoft.com/office/drawing/2014/main" id="{20948F27-B0C6-493C-E376-ECD9EA057842}"/>
+                <a16:creationId xmlns:a16="http://schemas.microsoft.com/office/drawing/2014/main" xmlns="" id="{20948F27-B0C6-493C-E376-ECD9EA057842}"/>
               </a:ext>
             </a:extLst>
           </p:cNvPr>
@@ -11409,7 +11409,7 @@
           <p:cNvPr id="2" name="標題 1">
             <a:extLst>
               <a:ext uri="{FF2B5EF4-FFF2-40B4-BE49-F238E27FC236}">
-                <a16:creationId xmlns:a16="http://schemas.microsoft.com/office/drawing/2014/main" id="{3FC49E13-5D0E-530F-BBC1-FC332D8028EF}"/>
+                <a16:creationId xmlns:a16="http://schemas.microsoft.com/office/drawing/2014/main" xmlns="" id="{3FC49E13-5D0E-530F-BBC1-FC332D8028EF}"/>
               </a:ext>
             </a:extLst>
           </p:cNvPr>
@@ -11466,7 +11466,7 @@
           <p:cNvPr id="6" name="文字方塊 5">
             <a:extLst>
               <a:ext uri="{FF2B5EF4-FFF2-40B4-BE49-F238E27FC236}">
-                <a16:creationId xmlns:a16="http://schemas.microsoft.com/office/drawing/2014/main" id="{27493041-3D15-7F7D-9474-913A932E6381}"/>
+                <a16:creationId xmlns:a16="http://schemas.microsoft.com/office/drawing/2014/main" xmlns="" id="{27493041-3D15-7F7D-9474-913A932E6381}"/>
               </a:ext>
             </a:extLst>
           </p:cNvPr>
@@ -11552,7 +11552,7 @@
           <p:cNvPr id="8" name="矩形 7">
             <a:extLst>
               <a:ext uri="{FF2B5EF4-FFF2-40B4-BE49-F238E27FC236}">
-                <a16:creationId xmlns:a16="http://schemas.microsoft.com/office/drawing/2014/main" id="{BD3AF849-7585-8E18-FE5B-39F9769ADA1A}"/>
+                <a16:creationId xmlns:a16="http://schemas.microsoft.com/office/drawing/2014/main" xmlns="" id="{BD3AF849-7585-8E18-FE5B-39F9769ADA1A}"/>
               </a:ext>
             </a:extLst>
           </p:cNvPr>
@@ -11602,7 +11602,7 @@
           <p:cNvPr id="9" name="矩形 8">
             <a:extLst>
               <a:ext uri="{FF2B5EF4-FFF2-40B4-BE49-F238E27FC236}">
-                <a16:creationId xmlns:a16="http://schemas.microsoft.com/office/drawing/2014/main" id="{D91EAE06-BAEB-2174-F37A-F160A02301FD}"/>
+                <a16:creationId xmlns:a16="http://schemas.microsoft.com/office/drawing/2014/main" xmlns="" id="{D91EAE06-BAEB-2174-F37A-F160A02301FD}"/>
               </a:ext>
             </a:extLst>
           </p:cNvPr>
@@ -11652,7 +11652,7 @@
           <p:cNvPr id="10" name="文字方塊 9">
             <a:extLst>
               <a:ext uri="{FF2B5EF4-FFF2-40B4-BE49-F238E27FC236}">
-                <a16:creationId xmlns:a16="http://schemas.microsoft.com/office/drawing/2014/main" id="{2153307F-2527-D731-67BC-D0DCE640A78C}"/>
+                <a16:creationId xmlns:a16="http://schemas.microsoft.com/office/drawing/2014/main" xmlns="" id="{2153307F-2527-D731-67BC-D0DCE640A78C}"/>
               </a:ext>
             </a:extLst>
           </p:cNvPr>
@@ -11692,7 +11692,7 @@
           <p:cNvPr id="12" name="圖片 11">
             <a:extLst>
               <a:ext uri="{FF2B5EF4-FFF2-40B4-BE49-F238E27FC236}">
-                <a16:creationId xmlns:a16="http://schemas.microsoft.com/office/drawing/2014/main" id="{3F1C7224-9C3E-6BED-B504-40144806E1D1}"/>
+                <a16:creationId xmlns:a16="http://schemas.microsoft.com/office/drawing/2014/main" xmlns="" id="{3F1C7224-9C3E-6BED-B504-40144806E1D1}"/>
               </a:ext>
             </a:extLst>
           </p:cNvPr>
@@ -11752,7 +11752,7 @@
           <p:cNvPr id="17" name="圖片 16">
             <a:extLst>
               <a:ext uri="{FF2B5EF4-FFF2-40B4-BE49-F238E27FC236}">
-                <a16:creationId xmlns:a16="http://schemas.microsoft.com/office/drawing/2014/main" id="{497293B2-2453-0736-617B-83934796DCD2}"/>
+                <a16:creationId xmlns:a16="http://schemas.microsoft.com/office/drawing/2014/main" xmlns="" id="{497293B2-2453-0736-617B-83934796DCD2}"/>
               </a:ext>
             </a:extLst>
           </p:cNvPr>
@@ -11782,7 +11782,7 @@
           <p:cNvPr id="8" name="圖片 7">
             <a:extLst>
               <a:ext uri="{FF2B5EF4-FFF2-40B4-BE49-F238E27FC236}">
-                <a16:creationId xmlns:a16="http://schemas.microsoft.com/office/drawing/2014/main" id="{387434EE-00D7-76CB-D334-997AA7EEA23D}"/>
+                <a16:creationId xmlns:a16="http://schemas.microsoft.com/office/drawing/2014/main" xmlns="" id="{387434EE-00D7-76CB-D334-997AA7EEA23D}"/>
               </a:ext>
             </a:extLst>
           </p:cNvPr>
@@ -11812,7 +11812,7 @@
           <p:cNvPr id="2" name="標題 1">
             <a:extLst>
               <a:ext uri="{FF2B5EF4-FFF2-40B4-BE49-F238E27FC236}">
-                <a16:creationId xmlns:a16="http://schemas.microsoft.com/office/drawing/2014/main" id="{AADBB2BB-D8FB-888B-98BB-0DD7366BE2F9}"/>
+                <a16:creationId xmlns:a16="http://schemas.microsoft.com/office/drawing/2014/main" xmlns="" id="{AADBB2BB-D8FB-888B-98BB-0DD7366BE2F9}"/>
               </a:ext>
             </a:extLst>
           </p:cNvPr>
@@ -11837,7 +11837,7 @@
           <p:cNvPr id="3" name="副標題 2">
             <a:extLst>
               <a:ext uri="{FF2B5EF4-FFF2-40B4-BE49-F238E27FC236}">
-                <a16:creationId xmlns:a16="http://schemas.microsoft.com/office/drawing/2014/main" id="{92A787FA-AE9C-6D57-4937-286A7E936228}"/>
+                <a16:creationId xmlns:a16="http://schemas.microsoft.com/office/drawing/2014/main" xmlns="" id="{92A787FA-AE9C-6D57-4937-286A7E936228}"/>
               </a:ext>
             </a:extLst>
           </p:cNvPr>
@@ -11862,7 +11862,7 @@
           <p:cNvPr id="5" name="圖片 4">
             <a:extLst>
               <a:ext uri="{FF2B5EF4-FFF2-40B4-BE49-F238E27FC236}">
-                <a16:creationId xmlns:a16="http://schemas.microsoft.com/office/drawing/2014/main" id="{2B51684B-62FA-3D53-37AD-A7D3E2492C14}"/>
+                <a16:creationId xmlns:a16="http://schemas.microsoft.com/office/drawing/2014/main" xmlns="" id="{2B51684B-62FA-3D53-37AD-A7D3E2492C14}"/>
               </a:ext>
             </a:extLst>
           </p:cNvPr>
@@ -11892,7 +11892,7 @@
           <p:cNvPr id="7" name="圖片 6">
             <a:extLst>
               <a:ext uri="{FF2B5EF4-FFF2-40B4-BE49-F238E27FC236}">
-                <a16:creationId xmlns:a16="http://schemas.microsoft.com/office/drawing/2014/main" id="{22028FA4-F06E-8C43-088A-A222FAA059A1}"/>
+                <a16:creationId xmlns:a16="http://schemas.microsoft.com/office/drawing/2014/main" xmlns="" id="{22028FA4-F06E-8C43-088A-A222FAA059A1}"/>
               </a:ext>
             </a:extLst>
           </p:cNvPr>
@@ -11922,7 +11922,7 @@
           <p:cNvPr id="9" name="圖片 8">
             <a:extLst>
               <a:ext uri="{FF2B5EF4-FFF2-40B4-BE49-F238E27FC236}">
-                <a16:creationId xmlns:a16="http://schemas.microsoft.com/office/drawing/2014/main" id="{9A8FDF59-5194-F392-62BE-D65F514917FC}"/>
+                <a16:creationId xmlns:a16="http://schemas.microsoft.com/office/drawing/2014/main" xmlns="" id="{9A8FDF59-5194-F392-62BE-D65F514917FC}"/>
               </a:ext>
             </a:extLst>
           </p:cNvPr>
@@ -11952,7 +11952,7 @@
           <p:cNvPr id="10" name="矩形 9">
             <a:extLst>
               <a:ext uri="{FF2B5EF4-FFF2-40B4-BE49-F238E27FC236}">
-                <a16:creationId xmlns:a16="http://schemas.microsoft.com/office/drawing/2014/main" id="{FC17593B-D54B-13D6-EDA5-A5B04A2CE7AF}"/>
+                <a16:creationId xmlns:a16="http://schemas.microsoft.com/office/drawing/2014/main" xmlns="" id="{FC17593B-D54B-13D6-EDA5-A5B04A2CE7AF}"/>
               </a:ext>
             </a:extLst>
           </p:cNvPr>
@@ -12002,7 +12002,7 @@
           <p:cNvPr id="11" name="矩形 10">
             <a:extLst>
               <a:ext uri="{FF2B5EF4-FFF2-40B4-BE49-F238E27FC236}">
-                <a16:creationId xmlns:a16="http://schemas.microsoft.com/office/drawing/2014/main" id="{362F633D-21F2-605A-CD51-4F36F417CE4C}"/>
+                <a16:creationId xmlns:a16="http://schemas.microsoft.com/office/drawing/2014/main" xmlns="" id="{362F633D-21F2-605A-CD51-4F36F417CE4C}"/>
               </a:ext>
             </a:extLst>
           </p:cNvPr>
@@ -12052,7 +12052,7 @@
           <p:cNvPr id="12" name="矩形 11">
             <a:extLst>
               <a:ext uri="{FF2B5EF4-FFF2-40B4-BE49-F238E27FC236}">
-                <a16:creationId xmlns:a16="http://schemas.microsoft.com/office/drawing/2014/main" id="{53F441F1-FDD4-023F-2708-9636F05A1A71}"/>
+                <a16:creationId xmlns:a16="http://schemas.microsoft.com/office/drawing/2014/main" xmlns="" id="{53F441F1-FDD4-023F-2708-9636F05A1A71}"/>
               </a:ext>
             </a:extLst>
           </p:cNvPr>
@@ -12102,7 +12102,7 @@
           <p:cNvPr id="13" name="矩形 12">
             <a:extLst>
               <a:ext uri="{FF2B5EF4-FFF2-40B4-BE49-F238E27FC236}">
-                <a16:creationId xmlns:a16="http://schemas.microsoft.com/office/drawing/2014/main" id="{C3AAFF02-9961-9C52-9F38-88413DF0FB40}"/>
+                <a16:creationId xmlns:a16="http://schemas.microsoft.com/office/drawing/2014/main" xmlns="" id="{C3AAFF02-9961-9C52-9F38-88413DF0FB40}"/>
               </a:ext>
             </a:extLst>
           </p:cNvPr>
@@ -12152,7 +12152,7 @@
           <p:cNvPr id="14" name="矩形 13">
             <a:extLst>
               <a:ext uri="{FF2B5EF4-FFF2-40B4-BE49-F238E27FC236}">
-                <a16:creationId xmlns:a16="http://schemas.microsoft.com/office/drawing/2014/main" id="{B8072F49-11EC-E2BC-33F7-2BE4126F22D3}"/>
+                <a16:creationId xmlns:a16="http://schemas.microsoft.com/office/drawing/2014/main" xmlns="" id="{B8072F49-11EC-E2BC-33F7-2BE4126F22D3}"/>
               </a:ext>
             </a:extLst>
           </p:cNvPr>
@@ -12202,7 +12202,7 @@
           <p:cNvPr id="4" name="文字方塊 3">
             <a:extLst>
               <a:ext uri="{FF2B5EF4-FFF2-40B4-BE49-F238E27FC236}">
-                <a16:creationId xmlns:a16="http://schemas.microsoft.com/office/drawing/2014/main" id="{708FF207-AC8D-6430-EB9C-5F8582D5EE4A}"/>
+                <a16:creationId xmlns:a16="http://schemas.microsoft.com/office/drawing/2014/main" xmlns="" id="{708FF207-AC8D-6430-EB9C-5F8582D5EE4A}"/>
               </a:ext>
             </a:extLst>
           </p:cNvPr>
@@ -12257,7 +12257,7 @@
           <p:cNvPr id="15" name="矩形 14">
             <a:extLst>
               <a:ext uri="{FF2B5EF4-FFF2-40B4-BE49-F238E27FC236}">
-                <a16:creationId xmlns:a16="http://schemas.microsoft.com/office/drawing/2014/main" id="{1FB095A2-453E-441E-037A-65B5143BA9EE}"/>
+                <a16:creationId xmlns:a16="http://schemas.microsoft.com/office/drawing/2014/main" xmlns="" id="{1FB095A2-453E-441E-037A-65B5143BA9EE}"/>
               </a:ext>
             </a:extLst>
           </p:cNvPr>
@@ -12307,7 +12307,7 @@
           <p:cNvPr id="18" name="矩形 17">
             <a:extLst>
               <a:ext uri="{FF2B5EF4-FFF2-40B4-BE49-F238E27FC236}">
-                <a16:creationId xmlns:a16="http://schemas.microsoft.com/office/drawing/2014/main" id="{350995BF-9D24-0343-A46F-61F037CE41BA}"/>
+                <a16:creationId xmlns:a16="http://schemas.microsoft.com/office/drawing/2014/main" xmlns="" id="{350995BF-9D24-0343-A46F-61F037CE41BA}"/>
               </a:ext>
             </a:extLst>
           </p:cNvPr>
@@ -12357,7 +12357,7 @@
           <p:cNvPr id="6" name="文字方塊 5">
             <a:extLst>
               <a:ext uri="{FF2B5EF4-FFF2-40B4-BE49-F238E27FC236}">
-                <a16:creationId xmlns:a16="http://schemas.microsoft.com/office/drawing/2014/main" id="{CE5B0F96-CD80-F32B-2867-243AA6E0B62B}"/>
+                <a16:creationId xmlns:a16="http://schemas.microsoft.com/office/drawing/2014/main" xmlns="" id="{CE5B0F96-CD80-F32B-2867-243AA6E0B62B}"/>
               </a:ext>
             </a:extLst>
           </p:cNvPr>
@@ -12396,7 +12396,7 @@
           <p:cNvPr id="19" name="直線單箭頭接點 18">
             <a:extLst>
               <a:ext uri="{FF2B5EF4-FFF2-40B4-BE49-F238E27FC236}">
-                <a16:creationId xmlns:a16="http://schemas.microsoft.com/office/drawing/2014/main" id="{AD94081C-6B5A-3DD5-B01B-B2B893FA2878}"/>
+                <a16:creationId xmlns:a16="http://schemas.microsoft.com/office/drawing/2014/main" xmlns="" id="{AD94081C-6B5A-3DD5-B01B-B2B893FA2878}"/>
               </a:ext>
             </a:extLst>
           </p:cNvPr>
@@ -12437,7 +12437,7 @@
           <p:cNvPr id="21" name="直線接點 20">
             <a:extLst>
               <a:ext uri="{FF2B5EF4-FFF2-40B4-BE49-F238E27FC236}">
-                <a16:creationId xmlns:a16="http://schemas.microsoft.com/office/drawing/2014/main" id="{23417E59-6171-4C7B-3A9E-D2C029223C1C}"/>
+                <a16:creationId xmlns:a16="http://schemas.microsoft.com/office/drawing/2014/main" xmlns="" id="{23417E59-6171-4C7B-3A9E-D2C029223C1C}"/>
               </a:ext>
             </a:extLst>
           </p:cNvPr>
@@ -12476,7 +12476,7 @@
           <p:cNvPr id="24" name="直線接點 23">
             <a:extLst>
               <a:ext uri="{FF2B5EF4-FFF2-40B4-BE49-F238E27FC236}">
-                <a16:creationId xmlns:a16="http://schemas.microsoft.com/office/drawing/2014/main" id="{320EC0B4-EAE3-EB6B-0F68-BFEF7BCCDD12}"/>
+                <a16:creationId xmlns:a16="http://schemas.microsoft.com/office/drawing/2014/main" xmlns="" id="{320EC0B4-EAE3-EB6B-0F68-BFEF7BCCDD12}"/>
               </a:ext>
             </a:extLst>
           </p:cNvPr>
@@ -12513,7 +12513,7 @@
           <p:cNvPr id="25" name="文字方塊 24">
             <a:extLst>
               <a:ext uri="{FF2B5EF4-FFF2-40B4-BE49-F238E27FC236}">
-                <a16:creationId xmlns:a16="http://schemas.microsoft.com/office/drawing/2014/main" id="{33022AC8-B920-7CC5-2041-7B48D84B20EB}"/>
+                <a16:creationId xmlns:a16="http://schemas.microsoft.com/office/drawing/2014/main" xmlns="" id="{33022AC8-B920-7CC5-2041-7B48D84B20EB}"/>
               </a:ext>
             </a:extLst>
           </p:cNvPr>
@@ -12547,6 +12547,169 @@
           </a:p>
         </p:txBody>
       </p:sp>
+      <p:sp>
+        <p:nvSpPr>
+          <p:cNvPr id="16" name="文字方塊 15"/>
+          <p:cNvSpPr txBox="1"/>
+          <p:nvPr/>
+        </p:nvSpPr>
+        <p:spPr>
+          <a:xfrm>
+            <a:off x="6226629" y="4223657"/>
+            <a:ext cx="1723549" cy="1323439"/>
+          </a:xfrm>
+          <a:prstGeom prst="rect">
+            <a:avLst/>
+          </a:prstGeom>
+          <a:noFill/>
+        </p:spPr>
+        <p:txBody>
+          <a:bodyPr wrap="none" rtlCol="0">
+            <a:spAutoFit/>
+          </a:bodyPr>
+          <a:lstStyle/>
+          <a:p>
+            <a:r>
+              <a:rPr lang="zh-TW" altLang="en-US" sz="2000" b="1" dirty="0" smtClean="0">
+                <a:solidFill>
+                  <a:srgbClr val="FF0000"/>
+                </a:solidFill>
+              </a:rPr>
+              <a:t>注意：</a:t>
+            </a:r>
+            <a:endParaRPr lang="en-US" altLang="zh-TW" sz="2000" b="1" dirty="0" smtClean="0">
+              <a:solidFill>
+                <a:srgbClr val="FF0000"/>
+              </a:solidFill>
+            </a:endParaRPr>
+          </a:p>
+          <a:p>
+            <a:r>
+              <a:rPr lang="zh-TW" altLang="en-US" sz="2000" b="1" dirty="0" smtClean="0">
+                <a:solidFill>
+                  <a:srgbClr val="FF0000"/>
+                </a:solidFill>
+              </a:rPr>
+              <a:t>是調整大小，</a:t>
+            </a:r>
+            <a:endParaRPr lang="en-US" altLang="zh-TW" sz="2000" b="1" dirty="0" smtClean="0">
+              <a:solidFill>
+                <a:srgbClr val="FF0000"/>
+              </a:solidFill>
+            </a:endParaRPr>
+          </a:p>
+          <a:p>
+            <a:r>
+              <a:rPr lang="zh-TW" altLang="en-US" sz="2000" b="1" dirty="0" smtClean="0">
+                <a:solidFill>
+                  <a:srgbClr val="FF0000"/>
+                </a:solidFill>
+              </a:rPr>
+              <a:t>不是上面那個</a:t>
+            </a:r>
+            <a:endParaRPr lang="en-US" altLang="zh-TW" sz="2000" b="1" dirty="0" smtClean="0">
+              <a:solidFill>
+                <a:srgbClr val="FF0000"/>
+              </a:solidFill>
+            </a:endParaRPr>
+          </a:p>
+          <a:p>
+            <a:r>
+              <a:rPr lang="zh-TW" altLang="en-US" sz="2000" b="1" dirty="0" smtClean="0">
+                <a:solidFill>
+                  <a:srgbClr val="FF0000"/>
+                </a:solidFill>
+              </a:rPr>
+              <a:t>畫布大小</a:t>
+            </a:r>
+            <a:endParaRPr lang="zh-TW" altLang="en-US" sz="2000" b="1" dirty="0">
+              <a:solidFill>
+                <a:srgbClr val="FF0000"/>
+              </a:solidFill>
+            </a:endParaRPr>
+          </a:p>
+        </p:txBody>
+      </p:sp>
+      <p:cxnSp>
+        <p:nvCxnSpPr>
+          <p:cNvPr id="23" name="直線單箭頭接點 22">
+            <a:extLst>
+              <a:ext uri="{FF2B5EF4-FFF2-40B4-BE49-F238E27FC236}">
+                <a16:creationId xmlns:a16="http://schemas.microsoft.com/office/drawing/2014/main" xmlns="" id="{AD94081C-6B5A-3DD5-B01B-B2B893FA2878}"/>
+              </a:ext>
+            </a:extLst>
+          </p:cNvPr>
+          <p:cNvCxnSpPr>
+            <a:stCxn id="16" idx="1"/>
+          </p:cNvCxnSpPr>
+          <p:nvPr/>
+        </p:nvCxnSpPr>
+        <p:spPr>
+          <a:xfrm flipH="1">
+            <a:off x="5756367" y="4885377"/>
+            <a:ext cx="470262" cy="193519"/>
+          </a:xfrm>
+          <a:prstGeom prst="straightConnector1">
+            <a:avLst/>
+          </a:prstGeom>
+          <a:ln w="38100">
+            <a:tailEnd type="triangle"/>
+          </a:ln>
+        </p:spPr>
+        <p:style>
+          <a:lnRef idx="1">
+            <a:schemeClr val="accent2"/>
+          </a:lnRef>
+          <a:fillRef idx="0">
+            <a:schemeClr val="accent2"/>
+          </a:fillRef>
+          <a:effectRef idx="0">
+            <a:schemeClr val="accent2"/>
+          </a:effectRef>
+          <a:fontRef idx="minor">
+            <a:schemeClr val="tx1"/>
+          </a:fontRef>
+        </p:style>
+      </p:cxnSp>
+      <p:cxnSp>
+        <p:nvCxnSpPr>
+          <p:cNvPr id="26" name="直線單箭頭接點 25">
+            <a:extLst>
+              <a:ext uri="{FF2B5EF4-FFF2-40B4-BE49-F238E27FC236}">
+                <a16:creationId xmlns:a16="http://schemas.microsoft.com/office/drawing/2014/main" xmlns="" id="{AD94081C-6B5A-3DD5-B01B-B2B893FA2878}"/>
+              </a:ext>
+            </a:extLst>
+          </p:cNvPr>
+          <p:cNvCxnSpPr/>
+          <p:nvPr/>
+        </p:nvCxnSpPr>
+        <p:spPr>
+          <a:xfrm flipH="1" flipV="1">
+            <a:off x="5884997" y="4030420"/>
+            <a:ext cx="341632" cy="663500"/>
+          </a:xfrm>
+          <a:prstGeom prst="straightConnector1">
+            <a:avLst/>
+          </a:prstGeom>
+          <a:ln w="38100">
+            <a:tailEnd type="triangle"/>
+          </a:ln>
+        </p:spPr>
+        <p:style>
+          <a:lnRef idx="1">
+            <a:schemeClr val="accent2"/>
+          </a:lnRef>
+          <a:fillRef idx="0">
+            <a:schemeClr val="accent2"/>
+          </a:fillRef>
+          <a:effectRef idx="0">
+            <a:schemeClr val="accent2"/>
+          </a:effectRef>
+          <a:fontRef idx="minor">
+            <a:schemeClr val="tx1"/>
+          </a:fontRef>
+        </p:style>
+      </p:cxnSp>
     </p:spTree>
     <p:extLst>
       <p:ext uri="{BB962C8B-B14F-4D97-AF65-F5344CB8AC3E}">
@@ -12629,7 +12792,7 @@
           <p:cNvPr id="4" name="內容版面配置區 2">
             <a:extLst>
               <a:ext uri="{FF2B5EF4-FFF2-40B4-BE49-F238E27FC236}">
-                <a16:creationId xmlns:a16="http://schemas.microsoft.com/office/drawing/2014/main" id="{1D0E8889-394E-45EB-AD63-27FE775FB222}"/>
+                <a16:creationId xmlns:a16="http://schemas.microsoft.com/office/drawing/2014/main" xmlns="" id="{1D0E8889-394E-45EB-AD63-27FE775FB222}"/>
               </a:ext>
             </a:extLst>
           </p:cNvPr>
@@ -12895,7 +13058,7 @@
           <p:cNvPr id="13" name="內容版面配置區 2">
             <a:extLst>
               <a:ext uri="{FF2B5EF4-FFF2-40B4-BE49-F238E27FC236}">
-                <a16:creationId xmlns:a16="http://schemas.microsoft.com/office/drawing/2014/main" id="{E152F854-344F-4960-BA94-BC426E9F991D}"/>
+                <a16:creationId xmlns:a16="http://schemas.microsoft.com/office/drawing/2014/main" xmlns="" id="{E152F854-344F-4960-BA94-BC426E9F991D}"/>
               </a:ext>
             </a:extLst>
           </p:cNvPr>
@@ -13312,7 +13475,7 @@
           <p:cNvPr id="11" name="圖片 10">
             <a:extLst>
               <a:ext uri="{FF2B5EF4-FFF2-40B4-BE49-F238E27FC236}">
-                <a16:creationId xmlns:a16="http://schemas.microsoft.com/office/drawing/2014/main" id="{4A28DCBE-70B4-479A-9D86-CCE9AE2F04C3}"/>
+                <a16:creationId xmlns:a16="http://schemas.microsoft.com/office/drawing/2014/main" xmlns="" id="{4A28DCBE-70B4-479A-9D86-CCE9AE2F04C3}"/>
               </a:ext>
             </a:extLst>
           </p:cNvPr>
@@ -13418,7 +13581,7 @@
           <p:cNvPr id="4" name="內容版面配置區 2">
             <a:extLst>
               <a:ext uri="{FF2B5EF4-FFF2-40B4-BE49-F238E27FC236}">
-                <a16:creationId xmlns:a16="http://schemas.microsoft.com/office/drawing/2014/main" id="{1D0E8889-394E-45EB-AD63-27FE775FB222}"/>
+                <a16:creationId xmlns:a16="http://schemas.microsoft.com/office/drawing/2014/main" xmlns="" id="{1D0E8889-394E-45EB-AD63-27FE775FB222}"/>
               </a:ext>
             </a:extLst>
           </p:cNvPr>
@@ -13684,7 +13847,7 @@
           <p:cNvPr id="15" name="內容版面配置區 2">
             <a:extLst>
               <a:ext uri="{FF2B5EF4-FFF2-40B4-BE49-F238E27FC236}">
-                <a16:creationId xmlns:a16="http://schemas.microsoft.com/office/drawing/2014/main" id="{35A4076F-EE29-4C0A-B9BA-8B8D4499A876}"/>
+                <a16:creationId xmlns:a16="http://schemas.microsoft.com/office/drawing/2014/main" xmlns="" id="{35A4076F-EE29-4C0A-B9BA-8B8D4499A876}"/>
               </a:ext>
             </a:extLst>
           </p:cNvPr>
@@ -14365,7 +14528,7 @@
           <p:cNvPr id="6" name="圖片 5">
             <a:extLst>
               <a:ext uri="{FF2B5EF4-FFF2-40B4-BE49-F238E27FC236}">
-                <a16:creationId xmlns:a16="http://schemas.microsoft.com/office/drawing/2014/main" id="{F5343B26-08E1-4A87-9B4F-426EFD05DDF5}"/>
+                <a16:creationId xmlns:a16="http://schemas.microsoft.com/office/drawing/2014/main" xmlns="" id="{F5343B26-08E1-4A87-9B4F-426EFD05DDF5}"/>
               </a:ext>
             </a:extLst>
           </p:cNvPr>
@@ -14478,7 +14641,7 @@
           <p:cNvPr id="4" name="內容版面配置區 2">
             <a:extLst>
               <a:ext uri="{FF2B5EF4-FFF2-40B4-BE49-F238E27FC236}">
-                <a16:creationId xmlns:a16="http://schemas.microsoft.com/office/drawing/2014/main" id="{1D0E8889-394E-45EB-AD63-27FE775FB222}"/>
+                <a16:creationId xmlns:a16="http://schemas.microsoft.com/office/drawing/2014/main" xmlns="" id="{1D0E8889-394E-45EB-AD63-27FE775FB222}"/>
               </a:ext>
             </a:extLst>
           </p:cNvPr>
@@ -14737,7 +14900,7 @@
           <p:cNvPr id="7" name="內容版面配置區 2">
             <a:extLst>
               <a:ext uri="{FF2B5EF4-FFF2-40B4-BE49-F238E27FC236}">
-                <a16:creationId xmlns:a16="http://schemas.microsoft.com/office/drawing/2014/main" id="{469B08A0-6F6A-43CD-9496-5801978A5A0B}"/>
+                <a16:creationId xmlns:a16="http://schemas.microsoft.com/office/drawing/2014/main" xmlns="" id="{469B08A0-6F6A-43CD-9496-5801978A5A0B}"/>
               </a:ext>
             </a:extLst>
           </p:cNvPr>
@@ -15022,7 +15185,7 @@
           <p:cNvPr id="6" name="圖片 5">
             <a:extLst>
               <a:ext uri="{FF2B5EF4-FFF2-40B4-BE49-F238E27FC236}">
-                <a16:creationId xmlns:a16="http://schemas.microsoft.com/office/drawing/2014/main" id="{E03D9FAF-BE63-4F57-897A-C6A55D58A76A}"/>
+                <a16:creationId xmlns:a16="http://schemas.microsoft.com/office/drawing/2014/main" xmlns="" id="{E03D9FAF-BE63-4F57-897A-C6A55D58A76A}"/>
               </a:ext>
             </a:extLst>
           </p:cNvPr>
@@ -15135,7 +15298,7 @@
           <p:cNvPr id="4" name="內容版面配置區 2">
             <a:extLst>
               <a:ext uri="{FF2B5EF4-FFF2-40B4-BE49-F238E27FC236}">
-                <a16:creationId xmlns:a16="http://schemas.microsoft.com/office/drawing/2014/main" id="{1D0E8889-394E-45EB-AD63-27FE775FB222}"/>
+                <a16:creationId xmlns:a16="http://schemas.microsoft.com/office/drawing/2014/main" xmlns="" id="{1D0E8889-394E-45EB-AD63-27FE775FB222}"/>
               </a:ext>
             </a:extLst>
           </p:cNvPr>
@@ -15394,7 +15557,7 @@
           <p:cNvPr id="7" name="內容版面配置區 2">
             <a:extLst>
               <a:ext uri="{FF2B5EF4-FFF2-40B4-BE49-F238E27FC236}">
-                <a16:creationId xmlns:a16="http://schemas.microsoft.com/office/drawing/2014/main" id="{469B08A0-6F6A-43CD-9496-5801978A5A0B}"/>
+                <a16:creationId xmlns:a16="http://schemas.microsoft.com/office/drawing/2014/main" xmlns="" id="{469B08A0-6F6A-43CD-9496-5801978A5A0B}"/>
               </a:ext>
             </a:extLst>
           </p:cNvPr>
@@ -15773,7 +15936,7 @@
           <p:cNvPr id="8" name="圖片 7">
             <a:extLst>
               <a:ext uri="{FF2B5EF4-FFF2-40B4-BE49-F238E27FC236}">
-                <a16:creationId xmlns:a16="http://schemas.microsoft.com/office/drawing/2014/main" id="{558F78D9-4277-4777-A183-50A8482B0B2E}"/>
+                <a16:creationId xmlns:a16="http://schemas.microsoft.com/office/drawing/2014/main" xmlns="" id="{558F78D9-4277-4777-A183-50A8482B0B2E}"/>
               </a:ext>
             </a:extLst>
           </p:cNvPr>
@@ -15886,7 +16049,7 @@
           <p:cNvPr id="4" name="內容版面配置區 2">
             <a:extLst>
               <a:ext uri="{FF2B5EF4-FFF2-40B4-BE49-F238E27FC236}">
-                <a16:creationId xmlns:a16="http://schemas.microsoft.com/office/drawing/2014/main" id="{1D0E8889-394E-45EB-AD63-27FE775FB222}"/>
+                <a16:creationId xmlns:a16="http://schemas.microsoft.com/office/drawing/2014/main" xmlns="" id="{1D0E8889-394E-45EB-AD63-27FE775FB222}"/>
               </a:ext>
             </a:extLst>
           </p:cNvPr>
@@ -16145,7 +16308,7 @@
           <p:cNvPr id="7" name="內容版面配置區 2">
             <a:extLst>
               <a:ext uri="{FF2B5EF4-FFF2-40B4-BE49-F238E27FC236}">
-                <a16:creationId xmlns:a16="http://schemas.microsoft.com/office/drawing/2014/main" id="{469B08A0-6F6A-43CD-9496-5801978A5A0B}"/>
+                <a16:creationId xmlns:a16="http://schemas.microsoft.com/office/drawing/2014/main" xmlns="" id="{469B08A0-6F6A-43CD-9496-5801978A5A0B}"/>
               </a:ext>
             </a:extLst>
           </p:cNvPr>
@@ -16478,7 +16641,7 @@
           <p:cNvPr id="6" name="圖片 5">
             <a:extLst>
               <a:ext uri="{FF2B5EF4-FFF2-40B4-BE49-F238E27FC236}">
-                <a16:creationId xmlns:a16="http://schemas.microsoft.com/office/drawing/2014/main" id="{38D5583A-E7C7-4998-9F0A-C77BF8E0DD4D}"/>
+                <a16:creationId xmlns:a16="http://schemas.microsoft.com/office/drawing/2014/main" xmlns="" id="{38D5583A-E7C7-4998-9F0A-C77BF8E0DD4D}"/>
               </a:ext>
             </a:extLst>
           </p:cNvPr>
@@ -16543,7 +16706,7 @@
           <p:cNvPr id="2" name="標題 1">
             <a:extLst>
               <a:ext uri="{FF2B5EF4-FFF2-40B4-BE49-F238E27FC236}">
-                <a16:creationId xmlns:a16="http://schemas.microsoft.com/office/drawing/2014/main" id="{21DEDB05-9AD6-A309-FE22-551A658162D9}"/>
+                <a16:creationId xmlns:a16="http://schemas.microsoft.com/office/drawing/2014/main" xmlns="" id="{21DEDB05-9AD6-A309-FE22-551A658162D9}"/>
               </a:ext>
             </a:extLst>
           </p:cNvPr>
@@ -16618,7 +16781,7 @@
           <p:cNvPr id="3" name="圖片 2">
             <a:extLst>
               <a:ext uri="{FF2B5EF4-FFF2-40B4-BE49-F238E27FC236}">
-                <a16:creationId xmlns:a16="http://schemas.microsoft.com/office/drawing/2014/main" id="{17F784A2-FAFD-4361-C732-34CA61974D47}"/>
+                <a16:creationId xmlns:a16="http://schemas.microsoft.com/office/drawing/2014/main" xmlns="" id="{17F784A2-FAFD-4361-C732-34CA61974D47}"/>
               </a:ext>
             </a:extLst>
           </p:cNvPr>
@@ -16648,7 +16811,7 @@
           <p:cNvPr id="6" name="矩形 5">
             <a:extLst>
               <a:ext uri="{FF2B5EF4-FFF2-40B4-BE49-F238E27FC236}">
-                <a16:creationId xmlns:a16="http://schemas.microsoft.com/office/drawing/2014/main" id="{C5078D62-9536-39D1-E82F-C1342D4DB025}"/>
+                <a16:creationId xmlns:a16="http://schemas.microsoft.com/office/drawing/2014/main" xmlns="" id="{C5078D62-9536-39D1-E82F-C1342D4DB025}"/>
               </a:ext>
             </a:extLst>
           </p:cNvPr>
@@ -16698,7 +16861,7 @@
           <p:cNvPr id="7" name="矩形 6">
             <a:extLst>
               <a:ext uri="{FF2B5EF4-FFF2-40B4-BE49-F238E27FC236}">
-                <a16:creationId xmlns:a16="http://schemas.microsoft.com/office/drawing/2014/main" id="{841C07BF-EFB7-D784-4B2A-AF2FDACB4C81}"/>
+                <a16:creationId xmlns:a16="http://schemas.microsoft.com/office/drawing/2014/main" xmlns="" id="{841C07BF-EFB7-D784-4B2A-AF2FDACB4C81}"/>
               </a:ext>
             </a:extLst>
           </p:cNvPr>
@@ -16748,7 +16911,7 @@
           <p:cNvPr id="4" name="文字方塊 3">
             <a:extLst>
               <a:ext uri="{FF2B5EF4-FFF2-40B4-BE49-F238E27FC236}">
-                <a16:creationId xmlns:a16="http://schemas.microsoft.com/office/drawing/2014/main" id="{80E4A1C6-47F7-239E-CAB9-85F285FAA61D}"/>
+                <a16:creationId xmlns:a16="http://schemas.microsoft.com/office/drawing/2014/main" xmlns="" id="{80E4A1C6-47F7-239E-CAB9-85F285FAA61D}"/>
               </a:ext>
             </a:extLst>
           </p:cNvPr>
@@ -16796,7 +16959,7 @@
           <p:cNvPr id="5" name="文字方塊 4">
             <a:extLst>
               <a:ext uri="{FF2B5EF4-FFF2-40B4-BE49-F238E27FC236}">
-                <a16:creationId xmlns:a16="http://schemas.microsoft.com/office/drawing/2014/main" id="{F6AE3E8E-1E28-965D-376D-69D72DE3100F}"/>
+                <a16:creationId xmlns:a16="http://schemas.microsoft.com/office/drawing/2014/main" xmlns="" id="{F6AE3E8E-1E28-965D-376D-69D72DE3100F}"/>
               </a:ext>
             </a:extLst>
           </p:cNvPr>
@@ -16851,7 +17014,7 @@
           <p:cNvPr id="8" name="圖片 7">
             <a:extLst>
               <a:ext uri="{FF2B5EF4-FFF2-40B4-BE49-F238E27FC236}">
-                <a16:creationId xmlns:a16="http://schemas.microsoft.com/office/drawing/2014/main" id="{069F9B57-D75E-9442-E6D0-AB648BF87EB8}"/>
+                <a16:creationId xmlns:a16="http://schemas.microsoft.com/office/drawing/2014/main" xmlns="" id="{069F9B57-D75E-9442-E6D0-AB648BF87EB8}"/>
               </a:ext>
             </a:extLst>
           </p:cNvPr>
@@ -16881,7 +17044,7 @@
           <p:cNvPr id="9" name="文字方塊 8">
             <a:extLst>
               <a:ext uri="{FF2B5EF4-FFF2-40B4-BE49-F238E27FC236}">
-                <a16:creationId xmlns:a16="http://schemas.microsoft.com/office/drawing/2014/main" id="{E1694FF6-834B-7CEB-27E6-DE2887CFE841}"/>
+                <a16:creationId xmlns:a16="http://schemas.microsoft.com/office/drawing/2014/main" xmlns="" id="{E1694FF6-834B-7CEB-27E6-DE2887CFE841}"/>
               </a:ext>
             </a:extLst>
           </p:cNvPr>
@@ -16920,7 +17083,7 @@
           <p:cNvPr id="10" name="直線單箭頭接點 9">
             <a:extLst>
               <a:ext uri="{FF2B5EF4-FFF2-40B4-BE49-F238E27FC236}">
-                <a16:creationId xmlns:a16="http://schemas.microsoft.com/office/drawing/2014/main" id="{902961B5-E020-BBFF-CF58-A21FEFA8B60A}"/>
+                <a16:creationId xmlns:a16="http://schemas.microsoft.com/office/drawing/2014/main" xmlns="" id="{902961B5-E020-BBFF-CF58-A21FEFA8B60A}"/>
               </a:ext>
             </a:extLst>
           </p:cNvPr>
@@ -17208,7 +17371,7 @@
           <p:cNvPr id="4" name="文字方塊 3">
             <a:extLst>
               <a:ext uri="{FF2B5EF4-FFF2-40B4-BE49-F238E27FC236}">
-                <a16:creationId xmlns:a16="http://schemas.microsoft.com/office/drawing/2014/main" id="{536D6D22-FE99-E3C7-30C9-F0F297872D46}"/>
+                <a16:creationId xmlns:a16="http://schemas.microsoft.com/office/drawing/2014/main" xmlns="" id="{536D6D22-FE99-E3C7-30C9-F0F297872D46}"/>
               </a:ext>
             </a:extLst>
           </p:cNvPr>
@@ -17301,7 +17464,7 @@
           <p:cNvPr id="3" name="圖片 2">
             <a:extLst>
               <a:ext uri="{FF2B5EF4-FFF2-40B4-BE49-F238E27FC236}">
-                <a16:creationId xmlns:a16="http://schemas.microsoft.com/office/drawing/2014/main" id="{0DB18568-297F-0BE0-B950-CB161F7BBC82}"/>
+                <a16:creationId xmlns:a16="http://schemas.microsoft.com/office/drawing/2014/main" xmlns="" id="{0DB18568-297F-0BE0-B950-CB161F7BBC82}"/>
               </a:ext>
             </a:extLst>
           </p:cNvPr>
@@ -17331,7 +17494,7 @@
           <p:cNvPr id="5" name="圖片 4">
             <a:extLst>
               <a:ext uri="{FF2B5EF4-FFF2-40B4-BE49-F238E27FC236}">
-                <a16:creationId xmlns:a16="http://schemas.microsoft.com/office/drawing/2014/main" id="{5825C9B5-4C01-B19C-4AC6-5E5750712DA6}"/>
+                <a16:creationId xmlns:a16="http://schemas.microsoft.com/office/drawing/2014/main" xmlns="" id="{5825C9B5-4C01-B19C-4AC6-5E5750712DA6}"/>
               </a:ext>
             </a:extLst>
           </p:cNvPr>
@@ -17361,7 +17524,7 @@
           <p:cNvPr id="6" name="文字方塊 5">
             <a:extLst>
               <a:ext uri="{FF2B5EF4-FFF2-40B4-BE49-F238E27FC236}">
-                <a16:creationId xmlns:a16="http://schemas.microsoft.com/office/drawing/2014/main" id="{D4550F33-2817-D8A0-DEF3-092EEE9222E4}"/>
+                <a16:creationId xmlns:a16="http://schemas.microsoft.com/office/drawing/2014/main" xmlns="" id="{D4550F33-2817-D8A0-DEF3-092EEE9222E4}"/>
               </a:ext>
             </a:extLst>
           </p:cNvPr>
@@ -17396,7 +17559,7 @@
           <p:cNvPr id="8" name="圖片 7">
             <a:extLst>
               <a:ext uri="{FF2B5EF4-FFF2-40B4-BE49-F238E27FC236}">
-                <a16:creationId xmlns:a16="http://schemas.microsoft.com/office/drawing/2014/main" id="{688D50FD-1FBB-CAA2-66F7-1AA21A19C307}"/>
+                <a16:creationId xmlns:a16="http://schemas.microsoft.com/office/drawing/2014/main" xmlns="" id="{688D50FD-1FBB-CAA2-66F7-1AA21A19C307}"/>
               </a:ext>
             </a:extLst>
           </p:cNvPr>
@@ -17426,7 +17589,7 @@
           <p:cNvPr id="10" name="圖片 9">
             <a:extLst>
               <a:ext uri="{FF2B5EF4-FFF2-40B4-BE49-F238E27FC236}">
-                <a16:creationId xmlns:a16="http://schemas.microsoft.com/office/drawing/2014/main" id="{FF3461C5-9112-0CB7-485D-F69E58029CE3}"/>
+                <a16:creationId xmlns:a16="http://schemas.microsoft.com/office/drawing/2014/main" xmlns="" id="{FF3461C5-9112-0CB7-485D-F69E58029CE3}"/>
               </a:ext>
             </a:extLst>
           </p:cNvPr>
@@ -17456,7 +17619,7 @@
           <p:cNvPr id="11" name="矩形 10">
             <a:extLst>
               <a:ext uri="{FF2B5EF4-FFF2-40B4-BE49-F238E27FC236}">
-                <a16:creationId xmlns:a16="http://schemas.microsoft.com/office/drawing/2014/main" id="{076E8C18-8F97-3B0B-8B46-72697D4B55B5}"/>
+                <a16:creationId xmlns:a16="http://schemas.microsoft.com/office/drawing/2014/main" xmlns="" id="{076E8C18-8F97-3B0B-8B46-72697D4B55B5}"/>
               </a:ext>
             </a:extLst>
           </p:cNvPr>
@@ -17506,7 +17669,7 @@
           <p:cNvPr id="12" name="矩形 11">
             <a:extLst>
               <a:ext uri="{FF2B5EF4-FFF2-40B4-BE49-F238E27FC236}">
-                <a16:creationId xmlns:a16="http://schemas.microsoft.com/office/drawing/2014/main" id="{6C879D43-EF09-97FA-D781-0A31111252ED}"/>
+                <a16:creationId xmlns:a16="http://schemas.microsoft.com/office/drawing/2014/main" xmlns="" id="{6C879D43-EF09-97FA-D781-0A31111252ED}"/>
               </a:ext>
             </a:extLst>
           </p:cNvPr>
@@ -17556,7 +17719,7 @@
           <p:cNvPr id="13" name="矩形 12">
             <a:extLst>
               <a:ext uri="{FF2B5EF4-FFF2-40B4-BE49-F238E27FC236}">
-                <a16:creationId xmlns:a16="http://schemas.microsoft.com/office/drawing/2014/main" id="{892CA2E4-B1D0-D268-1E60-E324CFA9D4D6}"/>
+                <a16:creationId xmlns:a16="http://schemas.microsoft.com/office/drawing/2014/main" xmlns="" id="{892CA2E4-B1D0-D268-1E60-E324CFA9D4D6}"/>
               </a:ext>
             </a:extLst>
           </p:cNvPr>
@@ -17606,7 +17769,7 @@
           <p:cNvPr id="15" name="矩形 14">
             <a:extLst>
               <a:ext uri="{FF2B5EF4-FFF2-40B4-BE49-F238E27FC236}">
-                <a16:creationId xmlns:a16="http://schemas.microsoft.com/office/drawing/2014/main" id="{8741C395-0666-FB8F-23AB-B26728FB0202}"/>
+                <a16:creationId xmlns:a16="http://schemas.microsoft.com/office/drawing/2014/main" xmlns="" id="{8741C395-0666-FB8F-23AB-B26728FB0202}"/>
               </a:ext>
             </a:extLst>
           </p:cNvPr>
@@ -17656,7 +17819,7 @@
           <p:cNvPr id="16" name="文字方塊 15">
             <a:extLst>
               <a:ext uri="{FF2B5EF4-FFF2-40B4-BE49-F238E27FC236}">
-                <a16:creationId xmlns:a16="http://schemas.microsoft.com/office/drawing/2014/main" id="{1EB96C38-911B-AF17-2A67-C5CC77BAA6E7}"/>
+                <a16:creationId xmlns:a16="http://schemas.microsoft.com/office/drawing/2014/main" xmlns="" id="{1EB96C38-911B-AF17-2A67-C5CC77BAA6E7}"/>
               </a:ext>
             </a:extLst>
           </p:cNvPr>
@@ -17695,7 +17858,7 @@
           <p:cNvPr id="17" name="矩形 16">
             <a:extLst>
               <a:ext uri="{FF2B5EF4-FFF2-40B4-BE49-F238E27FC236}">
-                <a16:creationId xmlns:a16="http://schemas.microsoft.com/office/drawing/2014/main" id="{D9F8E32F-00B2-1B56-86D6-71E036D64DE5}"/>
+                <a16:creationId xmlns:a16="http://schemas.microsoft.com/office/drawing/2014/main" xmlns="" id="{D9F8E32F-00B2-1B56-86D6-71E036D64DE5}"/>
               </a:ext>
             </a:extLst>
           </p:cNvPr>
@@ -17745,7 +17908,7 @@
           <p:cNvPr id="4" name="圖片 3">
             <a:extLst>
               <a:ext uri="{FF2B5EF4-FFF2-40B4-BE49-F238E27FC236}">
-                <a16:creationId xmlns:a16="http://schemas.microsoft.com/office/drawing/2014/main" id="{0CC0F6E2-C327-EA8D-73CC-3A50B94B0041}"/>
+                <a16:creationId xmlns:a16="http://schemas.microsoft.com/office/drawing/2014/main" xmlns="" id="{0CC0F6E2-C327-EA8D-73CC-3A50B94B0041}"/>
               </a:ext>
             </a:extLst>
           </p:cNvPr>
@@ -17775,7 +17938,7 @@
           <p:cNvPr id="7" name="矩形 6">
             <a:extLst>
               <a:ext uri="{FF2B5EF4-FFF2-40B4-BE49-F238E27FC236}">
-                <a16:creationId xmlns:a16="http://schemas.microsoft.com/office/drawing/2014/main" id="{4B6BE569-244D-031D-190E-C0D3AF1A4E6E}"/>
+                <a16:creationId xmlns:a16="http://schemas.microsoft.com/office/drawing/2014/main" xmlns="" id="{4B6BE569-244D-031D-190E-C0D3AF1A4E6E}"/>
               </a:ext>
             </a:extLst>
           </p:cNvPr>
@@ -17825,7 +17988,7 @@
           <p:cNvPr id="2" name="文字方塊 1">
             <a:extLst>
               <a:ext uri="{FF2B5EF4-FFF2-40B4-BE49-F238E27FC236}">
-                <a16:creationId xmlns:a16="http://schemas.microsoft.com/office/drawing/2014/main" id="{7F4CF156-E09B-AEA4-02BC-4B69EEE64FF4}"/>
+                <a16:creationId xmlns:a16="http://schemas.microsoft.com/office/drawing/2014/main" xmlns="" id="{7F4CF156-E09B-AEA4-02BC-4B69EEE64FF4}"/>
               </a:ext>
             </a:extLst>
           </p:cNvPr>
@@ -17886,7 +18049,7 @@
           <p:cNvPr id="14" name="圖片 13">
             <a:extLst>
               <a:ext uri="{FF2B5EF4-FFF2-40B4-BE49-F238E27FC236}">
-                <a16:creationId xmlns:a16="http://schemas.microsoft.com/office/drawing/2014/main" id="{C283D4EA-61F2-CD3B-27E4-5557E6DC5990}"/>
+                <a16:creationId xmlns:a16="http://schemas.microsoft.com/office/drawing/2014/main" xmlns="" id="{C283D4EA-61F2-CD3B-27E4-5557E6DC5990}"/>
               </a:ext>
             </a:extLst>
           </p:cNvPr>
@@ -17916,7 +18079,7 @@
           <p:cNvPr id="18" name="矩形 17">
             <a:extLst>
               <a:ext uri="{FF2B5EF4-FFF2-40B4-BE49-F238E27FC236}">
-                <a16:creationId xmlns:a16="http://schemas.microsoft.com/office/drawing/2014/main" id="{92CF4187-2B6B-220A-B524-9E4EF2D0DD28}"/>
+                <a16:creationId xmlns:a16="http://schemas.microsoft.com/office/drawing/2014/main" xmlns="" id="{92CF4187-2B6B-220A-B524-9E4EF2D0DD28}"/>
               </a:ext>
             </a:extLst>
           </p:cNvPr>
@@ -17996,7 +18159,7 @@
           <p:cNvPr id="3" name="圖片 2">
             <a:extLst>
               <a:ext uri="{FF2B5EF4-FFF2-40B4-BE49-F238E27FC236}">
-                <a16:creationId xmlns:a16="http://schemas.microsoft.com/office/drawing/2014/main" id="{F0F73E0C-371D-C650-60B1-DCA58186EE4D}"/>
+                <a16:creationId xmlns:a16="http://schemas.microsoft.com/office/drawing/2014/main" xmlns="" id="{F0F73E0C-371D-C650-60B1-DCA58186EE4D}"/>
               </a:ext>
             </a:extLst>
           </p:cNvPr>
@@ -18026,7 +18189,7 @@
           <p:cNvPr id="4" name="內容版面配置區 2">
             <a:extLst>
               <a:ext uri="{FF2B5EF4-FFF2-40B4-BE49-F238E27FC236}">
-                <a16:creationId xmlns:a16="http://schemas.microsoft.com/office/drawing/2014/main" id="{7C7C1215-EDE5-7FA7-14DE-314CD56C8E93}"/>
+                <a16:creationId xmlns:a16="http://schemas.microsoft.com/office/drawing/2014/main" xmlns="" id="{7C7C1215-EDE5-7FA7-14DE-314CD56C8E93}"/>
               </a:ext>
             </a:extLst>
           </p:cNvPr>
@@ -18388,7 +18551,7 @@
           <p:cNvPr id="6" name="圖片 5">
             <a:extLst>
               <a:ext uri="{FF2B5EF4-FFF2-40B4-BE49-F238E27FC236}">
-                <a16:creationId xmlns:a16="http://schemas.microsoft.com/office/drawing/2014/main" id="{925AACA4-3D48-3B52-A5BB-D85A9321D4AE}"/>
+                <a16:creationId xmlns:a16="http://schemas.microsoft.com/office/drawing/2014/main" xmlns="" id="{925AACA4-3D48-3B52-A5BB-D85A9321D4AE}"/>
               </a:ext>
             </a:extLst>
           </p:cNvPr>
@@ -18418,7 +18581,7 @@
           <p:cNvPr id="8" name="圖片 7">
             <a:extLst>
               <a:ext uri="{FF2B5EF4-FFF2-40B4-BE49-F238E27FC236}">
-                <a16:creationId xmlns:a16="http://schemas.microsoft.com/office/drawing/2014/main" id="{A5A53C94-0735-A63F-0F25-BB0C617E0B3D}"/>
+                <a16:creationId xmlns:a16="http://schemas.microsoft.com/office/drawing/2014/main" xmlns="" id="{A5A53C94-0735-A63F-0F25-BB0C617E0B3D}"/>
               </a:ext>
             </a:extLst>
           </p:cNvPr>
@@ -18448,7 +18611,7 @@
           <p:cNvPr id="10" name="圖片 9">
             <a:extLst>
               <a:ext uri="{FF2B5EF4-FFF2-40B4-BE49-F238E27FC236}">
-                <a16:creationId xmlns:a16="http://schemas.microsoft.com/office/drawing/2014/main" id="{3DBF16B6-CBA9-3D2E-A398-FD115A04A360}"/>
+                <a16:creationId xmlns:a16="http://schemas.microsoft.com/office/drawing/2014/main" xmlns="" id="{3DBF16B6-CBA9-3D2E-A398-FD115A04A360}"/>
               </a:ext>
             </a:extLst>
           </p:cNvPr>
@@ -18478,7 +18641,7 @@
           <p:cNvPr id="11" name="文字方塊 10">
             <a:extLst>
               <a:ext uri="{FF2B5EF4-FFF2-40B4-BE49-F238E27FC236}">
-                <a16:creationId xmlns:a16="http://schemas.microsoft.com/office/drawing/2014/main" id="{81FF47FD-2F3B-D731-1027-DFEE218490DE}"/>
+                <a16:creationId xmlns:a16="http://schemas.microsoft.com/office/drawing/2014/main" xmlns="" id="{81FF47FD-2F3B-D731-1027-DFEE218490DE}"/>
               </a:ext>
             </a:extLst>
           </p:cNvPr>
@@ -18561,7 +18724,7 @@
           <p:cNvPr id="12" name="矩形 11">
             <a:extLst>
               <a:ext uri="{FF2B5EF4-FFF2-40B4-BE49-F238E27FC236}">
-                <a16:creationId xmlns:a16="http://schemas.microsoft.com/office/drawing/2014/main" id="{4366586B-24A5-2954-6D0A-5A904BED0FE0}"/>
+                <a16:creationId xmlns:a16="http://schemas.microsoft.com/office/drawing/2014/main" xmlns="" id="{4366586B-24A5-2954-6D0A-5A904BED0FE0}"/>
               </a:ext>
             </a:extLst>
           </p:cNvPr>
@@ -18611,7 +18774,7 @@
           <p:cNvPr id="13" name="矩形 12">
             <a:extLst>
               <a:ext uri="{FF2B5EF4-FFF2-40B4-BE49-F238E27FC236}">
-                <a16:creationId xmlns:a16="http://schemas.microsoft.com/office/drawing/2014/main" id="{074F49D1-70F2-260C-FA28-5579555846B5}"/>
+                <a16:creationId xmlns:a16="http://schemas.microsoft.com/office/drawing/2014/main" xmlns="" id="{074F49D1-70F2-260C-FA28-5579555846B5}"/>
               </a:ext>
             </a:extLst>
           </p:cNvPr>
@@ -18661,7 +18824,7 @@
           <p:cNvPr id="14" name="文字方塊 13">
             <a:extLst>
               <a:ext uri="{FF2B5EF4-FFF2-40B4-BE49-F238E27FC236}">
-                <a16:creationId xmlns:a16="http://schemas.microsoft.com/office/drawing/2014/main" id="{3A31773D-2B40-D749-2CED-02573F4AD40C}"/>
+                <a16:creationId xmlns:a16="http://schemas.microsoft.com/office/drawing/2014/main" xmlns="" id="{3A31773D-2B40-D749-2CED-02573F4AD40C}"/>
               </a:ext>
             </a:extLst>
           </p:cNvPr>
@@ -18700,7 +18863,7 @@
           <p:cNvPr id="2" name="矩形 1">
             <a:extLst>
               <a:ext uri="{FF2B5EF4-FFF2-40B4-BE49-F238E27FC236}">
-                <a16:creationId xmlns:a16="http://schemas.microsoft.com/office/drawing/2014/main" id="{081B1960-179B-41B2-3179-FC2DC5A72261}"/>
+                <a16:creationId xmlns:a16="http://schemas.microsoft.com/office/drawing/2014/main" xmlns="" id="{081B1960-179B-41B2-3179-FC2DC5A72261}"/>
               </a:ext>
             </a:extLst>
           </p:cNvPr>
@@ -18750,7 +18913,7 @@
           <p:cNvPr id="5" name="矩形 4">
             <a:extLst>
               <a:ext uri="{FF2B5EF4-FFF2-40B4-BE49-F238E27FC236}">
-                <a16:creationId xmlns:a16="http://schemas.microsoft.com/office/drawing/2014/main" id="{518DF4EE-0A69-58E3-6B3D-6DB2A6D7E71F}"/>
+                <a16:creationId xmlns:a16="http://schemas.microsoft.com/office/drawing/2014/main" xmlns="" id="{518DF4EE-0A69-58E3-6B3D-6DB2A6D7E71F}"/>
               </a:ext>
             </a:extLst>
           </p:cNvPr>
@@ -18800,7 +18963,7 @@
           <p:cNvPr id="7" name="矩形 6">
             <a:extLst>
               <a:ext uri="{FF2B5EF4-FFF2-40B4-BE49-F238E27FC236}">
-                <a16:creationId xmlns:a16="http://schemas.microsoft.com/office/drawing/2014/main" id="{930FC9AC-B455-1EFC-AB4D-66E49C55ADE3}"/>
+                <a16:creationId xmlns:a16="http://schemas.microsoft.com/office/drawing/2014/main" xmlns="" id="{930FC9AC-B455-1EFC-AB4D-66E49C55ADE3}"/>
               </a:ext>
             </a:extLst>
           </p:cNvPr>
@@ -18880,7 +19043,7 @@
           <p:cNvPr id="3" name="圖片 2">
             <a:extLst>
               <a:ext uri="{FF2B5EF4-FFF2-40B4-BE49-F238E27FC236}">
-                <a16:creationId xmlns:a16="http://schemas.microsoft.com/office/drawing/2014/main" id="{270F3AC0-0E07-EC02-6616-06D53B0E1F28}"/>
+                <a16:creationId xmlns:a16="http://schemas.microsoft.com/office/drawing/2014/main" xmlns="" id="{270F3AC0-0E07-EC02-6616-06D53B0E1F28}"/>
               </a:ext>
             </a:extLst>
           </p:cNvPr>
@@ -18940,7 +19103,7 @@
           <p:cNvPr id="2" name="標題 1">
             <a:extLst>
               <a:ext uri="{FF2B5EF4-FFF2-40B4-BE49-F238E27FC236}">
-                <a16:creationId xmlns:a16="http://schemas.microsoft.com/office/drawing/2014/main" id="{2FDCC686-3FBA-7532-1257-C3E979AFD3EB}"/>
+                <a16:creationId xmlns:a16="http://schemas.microsoft.com/office/drawing/2014/main" xmlns="" id="{2FDCC686-3FBA-7532-1257-C3E979AFD3EB}"/>
               </a:ext>
             </a:extLst>
           </p:cNvPr>
@@ -19017,7 +19180,7 @@
           <p:cNvPr id="4" name="圖片 3">
             <a:extLst>
               <a:ext uri="{FF2B5EF4-FFF2-40B4-BE49-F238E27FC236}">
-                <a16:creationId xmlns:a16="http://schemas.microsoft.com/office/drawing/2014/main" id="{4E280D1C-8903-43FE-FAB6-4BCC79663B52}"/>
+                <a16:creationId xmlns:a16="http://schemas.microsoft.com/office/drawing/2014/main" xmlns="" id="{4E280D1C-8903-43FE-FAB6-4BCC79663B52}"/>
               </a:ext>
             </a:extLst>
           </p:cNvPr>
@@ -19047,7 +19210,7 @@
           <p:cNvPr id="6" name="圖片 5">
             <a:extLst>
               <a:ext uri="{FF2B5EF4-FFF2-40B4-BE49-F238E27FC236}">
-                <a16:creationId xmlns:a16="http://schemas.microsoft.com/office/drawing/2014/main" id="{F75C69F3-E55E-0F90-5EE9-83C50421505A}"/>
+                <a16:creationId xmlns:a16="http://schemas.microsoft.com/office/drawing/2014/main" xmlns="" id="{F75C69F3-E55E-0F90-5EE9-83C50421505A}"/>
               </a:ext>
             </a:extLst>
           </p:cNvPr>
@@ -19077,7 +19240,7 @@
           <p:cNvPr id="8" name="圖片 7">
             <a:extLst>
               <a:ext uri="{FF2B5EF4-FFF2-40B4-BE49-F238E27FC236}">
-                <a16:creationId xmlns:a16="http://schemas.microsoft.com/office/drawing/2014/main" id="{A301E3B2-9FC0-7CAC-A064-2C5BAC0F6A3F}"/>
+                <a16:creationId xmlns:a16="http://schemas.microsoft.com/office/drawing/2014/main" xmlns="" id="{A301E3B2-9FC0-7CAC-A064-2C5BAC0F6A3F}"/>
               </a:ext>
             </a:extLst>
           </p:cNvPr>
@@ -19107,7 +19270,7 @@
           <p:cNvPr id="12" name="圖片 11">
             <a:extLst>
               <a:ext uri="{FF2B5EF4-FFF2-40B4-BE49-F238E27FC236}">
-                <a16:creationId xmlns:a16="http://schemas.microsoft.com/office/drawing/2014/main" id="{3F4A982D-7046-CABC-958F-1EE8D74B6FEE}"/>
+                <a16:creationId xmlns:a16="http://schemas.microsoft.com/office/drawing/2014/main" xmlns="" id="{3F4A982D-7046-CABC-958F-1EE8D74B6FEE}"/>
               </a:ext>
             </a:extLst>
           </p:cNvPr>
@@ -19137,7 +19300,7 @@
           <p:cNvPr id="13" name="文字方塊 12">
             <a:extLst>
               <a:ext uri="{FF2B5EF4-FFF2-40B4-BE49-F238E27FC236}">
-                <a16:creationId xmlns:a16="http://schemas.microsoft.com/office/drawing/2014/main" id="{ADA7363D-F723-EE81-CDDF-79B2F10B1411}"/>
+                <a16:creationId xmlns:a16="http://schemas.microsoft.com/office/drawing/2014/main" xmlns="" id="{ADA7363D-F723-EE81-CDDF-79B2F10B1411}"/>
               </a:ext>
             </a:extLst>
           </p:cNvPr>
@@ -19201,7 +19364,7 @@
           <p:cNvPr id="5" name="圖片 4">
             <a:extLst>
               <a:ext uri="{FF2B5EF4-FFF2-40B4-BE49-F238E27FC236}">
-                <a16:creationId xmlns:a16="http://schemas.microsoft.com/office/drawing/2014/main" id="{74221F73-BBBC-F628-F7AA-6BB1C62599CE}"/>
+                <a16:creationId xmlns:a16="http://schemas.microsoft.com/office/drawing/2014/main" xmlns="" id="{74221F73-BBBC-F628-F7AA-6BB1C62599CE}"/>
               </a:ext>
             </a:extLst>
           </p:cNvPr>
@@ -19231,7 +19394,7 @@
           <p:cNvPr id="7" name="箭號: 向右 6">
             <a:extLst>
               <a:ext uri="{FF2B5EF4-FFF2-40B4-BE49-F238E27FC236}">
-                <a16:creationId xmlns:a16="http://schemas.microsoft.com/office/drawing/2014/main" id="{F1164B9E-529D-1BEB-562C-21B6C02A54A3}"/>
+                <a16:creationId xmlns:a16="http://schemas.microsoft.com/office/drawing/2014/main" xmlns="" id="{F1164B9E-529D-1BEB-562C-21B6C02A54A3}"/>
               </a:ext>
             </a:extLst>
           </p:cNvPr>
@@ -19307,7 +19470,7 @@
           <p:cNvPr id="2" name="標題 1">
             <a:extLst>
               <a:ext uri="{FF2B5EF4-FFF2-40B4-BE49-F238E27FC236}">
-                <a16:creationId xmlns:a16="http://schemas.microsoft.com/office/drawing/2014/main" id="{A58788F5-0151-90D8-5193-EF48362E6630}"/>
+                <a16:creationId xmlns:a16="http://schemas.microsoft.com/office/drawing/2014/main" xmlns="" id="{A58788F5-0151-90D8-5193-EF48362E6630}"/>
               </a:ext>
             </a:extLst>
           </p:cNvPr>
@@ -19336,7 +19499,7 @@
           <p:cNvPr id="3" name="文字方塊 2">
             <a:extLst>
               <a:ext uri="{FF2B5EF4-FFF2-40B4-BE49-F238E27FC236}">
-                <a16:creationId xmlns:a16="http://schemas.microsoft.com/office/drawing/2014/main" id="{8DB90282-C1D4-ABA3-7373-2F2F9C0750FB}"/>
+                <a16:creationId xmlns:a16="http://schemas.microsoft.com/office/drawing/2014/main" xmlns="" id="{8DB90282-C1D4-ABA3-7373-2F2F9C0750FB}"/>
               </a:ext>
             </a:extLst>
           </p:cNvPr>
@@ -19435,7 +19598,7 @@
           <p:cNvPr id="5" name="圖片 4">
             <a:extLst>
               <a:ext uri="{FF2B5EF4-FFF2-40B4-BE49-F238E27FC236}">
-                <a16:creationId xmlns:a16="http://schemas.microsoft.com/office/drawing/2014/main" id="{F67A750C-198F-044D-2954-2881B4989CF9}"/>
+                <a16:creationId xmlns:a16="http://schemas.microsoft.com/office/drawing/2014/main" xmlns="" id="{F67A750C-198F-044D-2954-2881B4989CF9}"/>
               </a:ext>
             </a:extLst>
           </p:cNvPr>
@@ -19465,7 +19628,7 @@
           <p:cNvPr id="7" name="圖片 6">
             <a:extLst>
               <a:ext uri="{FF2B5EF4-FFF2-40B4-BE49-F238E27FC236}">
-                <a16:creationId xmlns:a16="http://schemas.microsoft.com/office/drawing/2014/main" id="{47367C51-79F5-0A6B-F3BF-A30D863BEA77}"/>
+                <a16:creationId xmlns:a16="http://schemas.microsoft.com/office/drawing/2014/main" xmlns="" id="{47367C51-79F5-0A6B-F3BF-A30D863BEA77}"/>
               </a:ext>
             </a:extLst>
           </p:cNvPr>
@@ -19495,7 +19658,7 @@
           <p:cNvPr id="9" name="圖片 8">
             <a:extLst>
               <a:ext uri="{FF2B5EF4-FFF2-40B4-BE49-F238E27FC236}">
-                <a16:creationId xmlns:a16="http://schemas.microsoft.com/office/drawing/2014/main" id="{2175B18F-A4EB-10FE-00F9-51C891F1D24E}"/>
+                <a16:creationId xmlns:a16="http://schemas.microsoft.com/office/drawing/2014/main" xmlns="" id="{2175B18F-A4EB-10FE-00F9-51C891F1D24E}"/>
               </a:ext>
             </a:extLst>
           </p:cNvPr>
@@ -19822,7 +19985,7 @@
   <a:extraClrSchemeLst/>
   <a:extLst>
     <a:ext uri="{05A4C25C-085E-4340-85A3-A5531E510DB2}">
-      <thm15:themeFamily xmlns:thm15="http://schemas.microsoft.com/office/thememl/2012/main" name="Office Theme" id="{62F939B6-93AF-4DB8-9C6B-D6C7DFDC589F}" vid="{4A3C46E8-61CC-4603-A589-7422A47A8E4A}"/>
+      <thm15:themeFamily xmlns:thm15="http://schemas.microsoft.com/office/thememl/2012/main" xmlns="" name="Office Theme" id="{62F939B6-93AF-4DB8-9C6B-D6C7DFDC589F}" vid="{4A3C46E8-61CC-4603-A589-7422A47A8E4A}"/>
     </a:ext>
   </a:extLst>
 </a:theme>
@@ -20115,7 +20278,7 @@
   <a:extraClrSchemeLst/>
   <a:extLst>
     <a:ext uri="{05A4C25C-085E-4340-85A3-A5531E510DB2}">
-      <thm15:themeFamily xmlns:thm15="http://schemas.microsoft.com/office/thememl/2012/main" name="F1477" id="{8EDF6A5C-2665-47DE-847B-52B0E9AB61E4}" vid="{76908F37-AD7E-4B43-905C-6485C594D950}"/>
+      <thm15:themeFamily xmlns:thm15="http://schemas.microsoft.com/office/thememl/2012/main" xmlns="" name="F1477" id="{8EDF6A5C-2665-47DE-847B-52B0E9AB61E4}" vid="{76908F37-AD7E-4B43-905C-6485C594D950}"/>
     </a:ext>
   </a:extLst>
 </a:theme>
@@ -20410,7 +20573,7 @@
   <a:extraClrSchemeLst/>
   <a:extLst>
     <a:ext uri="{05A4C25C-085E-4340-85A3-A5531E510DB2}">
-      <thm15:themeFamily xmlns:thm15="http://schemas.microsoft.com/office/thememl/2012/main" name="Office Theme" id="{62F939B6-93AF-4DB8-9C6B-D6C7DFDC589F}" vid="{4A3C46E8-61CC-4603-A589-7422A47A8E4A}"/>
+      <thm15:themeFamily xmlns:thm15="http://schemas.microsoft.com/office/thememl/2012/main" xmlns="" name="Office Theme" id="{62F939B6-93AF-4DB8-9C6B-D6C7DFDC589F}" vid="{4A3C46E8-61CC-4603-A589-7422A47A8E4A}"/>
     </a:ext>
   </a:extLst>
 </a:theme>

</xml_diff>